<commit_message>
Added ppt, increased max stocks to be tested together in universe mode
</commit_message>
<xml_diff>
--- a/Darvas_Strategy_Rulebook_Deck_v2.pptx
+++ b/Darvas_Strategy_Rulebook_Deck_v2.pptx
@@ -15,6 +15,9 @@
     <p:sldId id="263" r:id="rId9"/>
     <p:sldId id="264" r:id="rId10"/>
     <p:sldId id="265" r:id="rId11"/>
+    <p:sldId id="266" r:id="rId16"/>
+    <p:sldId id="267" r:id="rId17"/>
+    <p:sldId id="268" r:id="rId18"/>
   </p:sldIdLst>
   <p:sldSz cx="12192000" cy="6858000"/>
   <p:notesSz cx="6858000" cy="9144000"/>
@@ -3884,6 +3887,3015 @@
             </a:pPr>
             <a:r>
               <a:t>This systematic strategy solves the single biggest flaw in equity investing: emotional decision-making. By combining high-velocity 5% swing harvesting during corrections with a patient multi-year trend-riding tranche, it delivers compounding wealth (+101.8% cash profit on INFY) with strict risk management.</a:t>
+            </a:r>
+          </a:p>
+        </p:txBody>
+      </p:sp>
+    </p:spTree>
+  </p:cSld>
+  <p:clrMapOvr>
+    <a:masterClrMapping/>
+  </p:clrMapOvr>
+</p:sld>
+</file>
+
+<file path=ppt/slides/slide11.xml><?xml version="1.0" encoding="utf-8"?>
+<p:sld xmlns:a="http://schemas.openxmlformats.org/drawingml/2006/main" xmlns:p="http://schemas.openxmlformats.org/presentationml/2006/main" xmlns:r="http://schemas.openxmlformats.org/officeDocument/2006/relationships">
+  <p:cSld>
+    <p:spTree>
+      <p:nvGrpSpPr>
+        <p:cNvPr id="1" name=""/>
+        <p:cNvGrpSpPr/>
+        <p:nvPr/>
+      </p:nvGrpSpPr>
+      <p:grpSpPr/>
+      <p:sp>
+        <p:nvSpPr>
+          <p:cNvPr id="2" name="Rectangle 1"/>
+          <p:cNvSpPr/>
+          <p:nvPr/>
+        </p:nvSpPr>
+        <p:spPr>
+          <a:xfrm>
+            <a:off x="0" y="0"/>
+            <a:ext cx="12191695" cy="6858000"/>
+          </a:xfrm>
+          <a:prstGeom prst="rect">
+            <a:avLst/>
+          </a:prstGeom>
+          <a:solidFill>
+            <a:srgbClr val="F8FAFC"/>
+          </a:solidFill>
+          <a:ln>
+            <a:solidFill>
+              <a:srgbClr val="F8FAFC"/>
+            </a:solidFill>
+          </a:ln>
+        </p:spPr>
+        <p:style>
+          <a:lnRef idx="1">
+            <a:schemeClr val="accent1"/>
+          </a:lnRef>
+          <a:fillRef idx="3">
+            <a:schemeClr val="accent1"/>
+          </a:fillRef>
+          <a:effectRef idx="2">
+            <a:schemeClr val="accent1"/>
+          </a:effectRef>
+          <a:fontRef idx="minor">
+            <a:schemeClr val="lt1"/>
+          </a:fontRef>
+        </p:style>
+        <p:txBody>
+          <a:bodyPr rtlCol="0" anchor="ctr"/>
+          <a:lstStyle/>
+          <a:p>
+            <a:pPr algn="ctr"/>
+          </a:p>
+        </p:txBody>
+      </p:sp>
+      <p:sp>
+        <p:nvSpPr>
+          <p:cNvPr id="3" name="TextBox 2"/>
+          <p:cNvSpPr txBox="1"/>
+          <p:nvPr/>
+        </p:nvSpPr>
+        <p:spPr>
+          <a:xfrm>
+            <a:off x="731520" y="365760"/>
+            <a:ext cx="10698480" cy="822960"/>
+          </a:xfrm>
+          <a:prstGeom prst="rect">
+            <a:avLst/>
+          </a:prstGeom>
+          <a:noFill/>
+        </p:spPr>
+        <p:txBody>
+          <a:bodyPr wrap="square" lIns="0" tIns="0" rIns="0" bIns="0">
+            <a:spAutoFit/>
+          </a:bodyPr>
+          <a:lstStyle/>
+          <a:p>
+            <a:pPr>
+              <a:defRPr sz="1000" b="1">
+                <a:solidFill>
+                  <a:srgbClr val="2563EB"/>
+                </a:solidFill>
+              </a:defRPr>
+            </a:pPr>
+            <a:r>
+              <a:t>STRATEGY VARIANT BACKTEST (2020 – 2026)</a:t>
+            </a:r>
+          </a:p>
+          <a:p>
+            <a:pPr>
+              <a:defRPr sz="2200" b="1">
+                <a:solidFill>
+                  <a:srgbClr val="0F172A"/>
+                </a:solidFill>
+              </a:defRPr>
+            </a:pPr>
+            <a:r>
+              <a:t>Nifty 50: CAR Filter vs No CAR Full Performance Ledger</a:t>
+            </a:r>
+          </a:p>
+        </p:txBody>
+      </p:sp>
+      <p:sp>
+        <p:nvSpPr>
+          <p:cNvPr id="4" name="Rectangle 3"/>
+          <p:cNvSpPr/>
+          <p:nvPr/>
+        </p:nvSpPr>
+        <p:spPr>
+          <a:xfrm>
+            <a:off x="731520" y="1234440"/>
+            <a:ext cx="10728655" cy="18288"/>
+          </a:xfrm>
+          <a:prstGeom prst="rect">
+            <a:avLst/>
+          </a:prstGeom>
+          <a:solidFill>
+            <a:srgbClr val="E2E8F0"/>
+          </a:solidFill>
+          <a:ln>
+            <a:solidFill>
+              <a:srgbClr val="E2E8F0"/>
+            </a:solidFill>
+          </a:ln>
+        </p:spPr>
+        <p:style>
+          <a:lnRef idx="1">
+            <a:schemeClr val="accent1"/>
+          </a:lnRef>
+          <a:fillRef idx="3">
+            <a:schemeClr val="accent1"/>
+          </a:fillRef>
+          <a:effectRef idx="2">
+            <a:schemeClr val="accent1"/>
+          </a:effectRef>
+          <a:fontRef idx="minor">
+            <a:schemeClr val="lt1"/>
+          </a:fontRef>
+        </p:style>
+        <p:txBody>
+          <a:bodyPr rtlCol="0" anchor="ctr"/>
+          <a:lstStyle/>
+          <a:p>
+            <a:pPr algn="ctr"/>
+          </a:p>
+        </p:txBody>
+      </p:sp>
+      <p:graphicFrame>
+        <p:nvGraphicFramePr>
+          <p:cNvPr id="5" name="Table 4"/>
+          <p:cNvGraphicFramePr>
+            <a:graphicFrameLocks noGrp="1"/>
+          </p:cNvGraphicFramePr>
+          <p:nvPr/>
+        </p:nvGraphicFramePr>
+        <p:xfrm>
+          <a:off x="731520" y="1417320"/>
+          <a:ext cx="6492240" cy="5029200"/>
+        </p:xfrm>
+        <a:graphic>
+          <a:graphicData uri="http://schemas.openxmlformats.org/drawingml/2006/table">
+            <a:tbl>
+              <a:tblPr firstRow="1" bandRow="1">
+                <a:tableStyleId>{5C22544A-7EE6-4342-B048-85BDC9FD1C3A}</a:tableStyleId>
+              </a:tblPr>
+              <a:tblGrid>
+                <a:gridCol w="2286000"/>
+                <a:gridCol w="1371600"/>
+                <a:gridCol w="1463040"/>
+                <a:gridCol w="1371600"/>
+              </a:tblGrid>
+              <a:tr h="359228">
+                <a:tc>
+                  <a:txBody>
+                    <a:bodyPr/>
+                    <a:lstStyle/>
+                    <a:p>
+                      <a:pPr algn="l">
+                        <a:defRPr sz="950" b="1">
+                          <a:solidFill>
+                            <a:srgbClr val="FFFFFF"/>
+                          </a:solidFill>
+                        </a:defRPr>
+                      </a:pPr>
+                      <a:r>
+                        <a:t>Metric / Parameter</a:t>
+                      </a:r>
+                    </a:p>
+                  </a:txBody>
+                  <a:tcPr>
+                    <a:solidFill>
+                      <a:srgbClr val="0F172A"/>
+                    </a:solidFill>
+                  </a:tcPr>
+                </a:tc>
+                <a:tc>
+                  <a:txBody>
+                    <a:bodyPr/>
+                    <a:lstStyle/>
+                    <a:p>
+                      <a:pPr algn="ctr">
+                        <a:defRPr sz="950" b="1">
+                          <a:solidFill>
+                            <a:srgbClr val="FFFFFF"/>
+                          </a:solidFill>
+                        </a:defRPr>
+                      </a:pPr>
+                      <a:r>
+                        <a:t>WITH CAR Filter</a:t>
+                      </a:r>
+                    </a:p>
+                  </a:txBody>
+                  <a:tcPr>
+                    <a:solidFill>
+                      <a:srgbClr val="0F172A"/>
+                    </a:solidFill>
+                  </a:tcPr>
+                </a:tc>
+                <a:tc>
+                  <a:txBody>
+                    <a:bodyPr/>
+                    <a:lstStyle/>
+                    <a:p>
+                      <a:pPr algn="ctr">
+                        <a:defRPr sz="950" b="1">
+                          <a:solidFill>
+                            <a:srgbClr val="FFFFFF"/>
+                          </a:solidFill>
+                        </a:defRPr>
+                      </a:pPr>
+                      <a:r>
+                        <a:t>WITHOUT CAR (Baseline)</a:t>
+                      </a:r>
+                    </a:p>
+                  </a:txBody>
+                  <a:tcPr>
+                    <a:solidFill>
+                      <a:srgbClr val="0F172A"/>
+                    </a:solidFill>
+                  </a:tcPr>
+                </a:tc>
+                <a:tc>
+                  <a:txBody>
+                    <a:bodyPr/>
+                    <a:lstStyle/>
+                    <a:p>
+                      <a:pPr algn="ctr">
+                        <a:defRPr sz="950" b="1">
+                          <a:solidFill>
+                            <a:srgbClr val="FFFFFF"/>
+                          </a:solidFill>
+                        </a:defRPr>
+                      </a:pPr>
+                      <a:r>
+                        <a:t>Impact / Advantage</a:t>
+                      </a:r>
+                    </a:p>
+                  </a:txBody>
+                  <a:tcPr>
+                    <a:solidFill>
+                      <a:srgbClr val="0F172A"/>
+                    </a:solidFill>
+                  </a:tcPr>
+                </a:tc>
+              </a:tr>
+              <a:tr h="359228">
+                <a:tc>
+                  <a:txBody>
+                    <a:bodyPr/>
+                    <a:lstStyle/>
+                    <a:p>
+                      <a:pPr algn="l">
+                        <a:defRPr sz="850">
+                          <a:solidFill>
+                            <a:srgbClr val="0F172A"/>
+                          </a:solidFill>
+                        </a:defRPr>
+                      </a:pPr>
+                      <a:r>
+                        <a:t>Total Portfolio Return</a:t>
+                      </a:r>
+                    </a:p>
+                  </a:txBody>
+                  <a:tcPr>
+                    <a:solidFill>
+                      <a:srgbClr val="F1F5F9"/>
+                    </a:solidFill>
+                  </a:tcPr>
+                </a:tc>
+                <a:tc>
+                  <a:txBody>
+                    <a:bodyPr/>
+                    <a:lstStyle/>
+                    <a:p>
+                      <a:pPr algn="ctr">
+                        <a:defRPr sz="850">
+                          <a:solidFill>
+                            <a:srgbClr val="0F172A"/>
+                          </a:solidFill>
+                        </a:defRPr>
+                      </a:pPr>
+                      <a:r>
+                        <a:t>+Rs. 21.40 Lakhs</a:t>
+                      </a:r>
+                    </a:p>
+                  </a:txBody>
+                  <a:tcPr>
+                    <a:solidFill>
+                      <a:srgbClr val="F1F5F9"/>
+                    </a:solidFill>
+                  </a:tcPr>
+                </a:tc>
+                <a:tc>
+                  <a:txBody>
+                    <a:bodyPr/>
+                    <a:lstStyle/>
+                    <a:p>
+                      <a:pPr algn="ctr">
+                        <a:defRPr sz="850" b="1">
+                          <a:solidFill>
+                            <a:srgbClr val="059669"/>
+                          </a:solidFill>
+                        </a:defRPr>
+                      </a:pPr>
+                      <a:r>
+                        <a:t>+Rs. 42.67 Lakhs</a:t>
+                      </a:r>
+                    </a:p>
+                  </a:txBody>
+                  <a:tcPr>
+                    <a:solidFill>
+                      <a:srgbClr val="F1F5F9"/>
+                    </a:solidFill>
+                  </a:tcPr>
+                </a:tc>
+                <a:tc>
+                  <a:txBody>
+                    <a:bodyPr/>
+                    <a:lstStyle/>
+                    <a:p>
+                      <a:pPr algn="ctr">
+                        <a:defRPr sz="850" b="1">
+                          <a:solidFill>
+                            <a:srgbClr val="7C3AED"/>
+                          </a:solidFill>
+                        </a:defRPr>
+                      </a:pPr>
+                      <a:r>
+                        <a:t>+Rs. 21.28L (2x Gain)</a:t>
+                      </a:r>
+                    </a:p>
+                  </a:txBody>
+                  <a:tcPr>
+                    <a:solidFill>
+                      <a:srgbClr val="F1F5F9"/>
+                    </a:solidFill>
+                  </a:tcPr>
+                </a:tc>
+              </a:tr>
+              <a:tr h="359228">
+                <a:tc>
+                  <a:txBody>
+                    <a:bodyPr/>
+                    <a:lstStyle/>
+                    <a:p>
+                      <a:pPr algn="l">
+                        <a:defRPr sz="850">
+                          <a:solidFill>
+                            <a:srgbClr val="0F172A"/>
+                          </a:solidFill>
+                        </a:defRPr>
+                      </a:pPr>
+                      <a:r>
+                        <a:t>Total Portfolio Return %</a:t>
+                      </a:r>
+                    </a:p>
+                  </a:txBody>
+                  <a:tcPr>
+                    <a:solidFill>
+                      <a:srgbClr val="FFFFFF"/>
+                    </a:solidFill>
+                  </a:tcPr>
+                </a:tc>
+                <a:tc>
+                  <a:txBody>
+                    <a:bodyPr/>
+                    <a:lstStyle/>
+                    <a:p>
+                      <a:pPr algn="ctr">
+                        <a:defRPr sz="850">
+                          <a:solidFill>
+                            <a:srgbClr val="0F172A"/>
+                          </a:solidFill>
+                        </a:defRPr>
+                      </a:pPr>
+                      <a:r>
+                        <a:t>+42.79%</a:t>
+                      </a:r>
+                    </a:p>
+                  </a:txBody>
+                  <a:tcPr>
+                    <a:solidFill>
+                      <a:srgbClr val="FFFFFF"/>
+                    </a:solidFill>
+                  </a:tcPr>
+                </a:tc>
+                <a:tc>
+                  <a:txBody>
+                    <a:bodyPr/>
+                    <a:lstStyle/>
+                    <a:p>
+                      <a:pPr algn="ctr">
+                        <a:defRPr sz="850" b="1">
+                          <a:solidFill>
+                            <a:srgbClr val="059669"/>
+                          </a:solidFill>
+                        </a:defRPr>
+                      </a:pPr>
+                      <a:r>
+                        <a:t>+85.35%</a:t>
+                      </a:r>
+                    </a:p>
+                  </a:txBody>
+                  <a:tcPr>
+                    <a:solidFill>
+                      <a:srgbClr val="FFFFFF"/>
+                    </a:solidFill>
+                  </a:tcPr>
+                </a:tc>
+                <a:tc>
+                  <a:txBody>
+                    <a:bodyPr/>
+                    <a:lstStyle/>
+                    <a:p>
+                      <a:pPr algn="ctr">
+                        <a:defRPr sz="850" b="1">
+                          <a:solidFill>
+                            <a:srgbClr val="7C3AED"/>
+                          </a:solidFill>
+                        </a:defRPr>
+                      </a:pPr>
+                      <a:r>
+                        <a:t>+42.56% Outperformance</a:t>
+                      </a:r>
+                    </a:p>
+                  </a:txBody>
+                  <a:tcPr>
+                    <a:solidFill>
+                      <a:srgbClr val="FFFFFF"/>
+                    </a:solidFill>
+                  </a:tcPr>
+                </a:tc>
+              </a:tr>
+              <a:tr h="359228">
+                <a:tc>
+                  <a:txBody>
+                    <a:bodyPr/>
+                    <a:lstStyle/>
+                    <a:p>
+                      <a:pPr algn="l">
+                        <a:defRPr sz="850">
+                          <a:solidFill>
+                            <a:srgbClr val="0F172A"/>
+                          </a:solidFill>
+                        </a:defRPr>
+                      </a:pPr>
+                      <a:r>
+                        <a:t>Total Realized Profit</a:t>
+                      </a:r>
+                    </a:p>
+                  </a:txBody>
+                  <a:tcPr>
+                    <a:solidFill>
+                      <a:srgbClr val="F1F5F9"/>
+                    </a:solidFill>
+                  </a:tcPr>
+                </a:tc>
+                <a:tc>
+                  <a:txBody>
+                    <a:bodyPr/>
+                    <a:lstStyle/>
+                    <a:p>
+                      <a:pPr algn="ctr">
+                        <a:defRPr sz="850">
+                          <a:solidFill>
+                            <a:srgbClr val="0F172A"/>
+                          </a:solidFill>
+                        </a:defRPr>
+                      </a:pPr>
+                      <a:r>
+                        <a:t>Rs. 20.72 Lakhs</a:t>
+                      </a:r>
+                    </a:p>
+                  </a:txBody>
+                  <a:tcPr>
+                    <a:solidFill>
+                      <a:srgbClr val="F1F5F9"/>
+                    </a:solidFill>
+                  </a:tcPr>
+                </a:tc>
+                <a:tc>
+                  <a:txBody>
+                    <a:bodyPr/>
+                    <a:lstStyle/>
+                    <a:p>
+                      <a:pPr algn="ctr">
+                        <a:defRPr sz="850" b="1">
+                          <a:solidFill>
+                            <a:srgbClr val="059669"/>
+                          </a:solidFill>
+                        </a:defRPr>
+                      </a:pPr>
+                      <a:r>
+                        <a:t>Rs. 45.53 Lakhs</a:t>
+                      </a:r>
+                    </a:p>
+                  </a:txBody>
+                  <a:tcPr>
+                    <a:solidFill>
+                      <a:srgbClr val="F1F5F9"/>
+                    </a:solidFill>
+                  </a:tcPr>
+                </a:tc>
+                <a:tc>
+                  <a:txBody>
+                    <a:bodyPr/>
+                    <a:lstStyle/>
+                    <a:p>
+                      <a:pPr algn="ctr">
+                        <a:defRPr sz="850" b="1">
+                          <a:solidFill>
+                            <a:srgbClr val="7C3AED"/>
+                          </a:solidFill>
+                        </a:defRPr>
+                      </a:pPr>
+                      <a:r>
+                        <a:t>+Rs. 24.81L Banked Cash</a:t>
+                      </a:r>
+                    </a:p>
+                  </a:txBody>
+                  <a:tcPr>
+                    <a:solidFill>
+                      <a:srgbClr val="F1F5F9"/>
+                    </a:solidFill>
+                  </a:tcPr>
+                </a:tc>
+              </a:tr>
+              <a:tr h="359228">
+                <a:tc>
+                  <a:txBody>
+                    <a:bodyPr/>
+                    <a:lstStyle/>
+                    <a:p>
+                      <a:pPr algn="l">
+                        <a:defRPr sz="850">
+                          <a:solidFill>
+                            <a:srgbClr val="0F172A"/>
+                          </a:solidFill>
+                        </a:defRPr>
+                      </a:pPr>
+                      <a:r>
+                        <a:t>  - Trade Realized Profit</a:t>
+                      </a:r>
+                    </a:p>
+                  </a:txBody>
+                  <a:tcPr>
+                    <a:solidFill>
+                      <a:srgbClr val="FFFFFF"/>
+                    </a:solidFill>
+                  </a:tcPr>
+                </a:tc>
+                <a:tc>
+                  <a:txBody>
+                    <a:bodyPr/>
+                    <a:lstStyle/>
+                    <a:p>
+                      <a:pPr algn="ctr">
+                        <a:defRPr sz="850">
+                          <a:solidFill>
+                            <a:srgbClr val="0F172A"/>
+                          </a:solidFill>
+                        </a:defRPr>
+                      </a:pPr>
+                      <a:r>
+                        <a:t>Rs. 15.17 Lakhs</a:t>
+                      </a:r>
+                    </a:p>
+                  </a:txBody>
+                  <a:tcPr>
+                    <a:solidFill>
+                      <a:srgbClr val="FFFFFF"/>
+                    </a:solidFill>
+                  </a:tcPr>
+                </a:tc>
+                <a:tc>
+                  <a:txBody>
+                    <a:bodyPr/>
+                    <a:lstStyle/>
+                    <a:p>
+                      <a:pPr algn="ctr">
+                        <a:defRPr sz="850" b="1">
+                          <a:solidFill>
+                            <a:srgbClr val="059669"/>
+                          </a:solidFill>
+                        </a:defRPr>
+                      </a:pPr>
+                      <a:r>
+                        <a:t>Rs. 33.20 Lakhs</a:t>
+                      </a:r>
+                    </a:p>
+                  </a:txBody>
+                  <a:tcPr>
+                    <a:solidFill>
+                      <a:srgbClr val="FFFFFF"/>
+                    </a:solidFill>
+                  </a:tcPr>
+                </a:tc>
+                <a:tc>
+                  <a:txBody>
+                    <a:bodyPr/>
+                    <a:lstStyle/>
+                    <a:p>
+                      <a:pPr algn="ctr">
+                        <a:defRPr sz="850" b="1">
+                          <a:solidFill>
+                            <a:srgbClr val="7C3AED"/>
+                          </a:solidFill>
+                        </a:defRPr>
+                      </a:pPr>
+                      <a:r>
+                        <a:t>+Rs. 18.03L from 5% Exits</a:t>
+                      </a:r>
+                    </a:p>
+                  </a:txBody>
+                  <a:tcPr>
+                    <a:solidFill>
+                      <a:srgbClr val="FFFFFF"/>
+                    </a:solidFill>
+                  </a:tcPr>
+                </a:tc>
+              </a:tr>
+              <a:tr h="359228">
+                <a:tc>
+                  <a:txBody>
+                    <a:bodyPr/>
+                    <a:lstStyle/>
+                    <a:p>
+                      <a:pPr algn="l">
+                        <a:defRPr sz="850">
+                          <a:solidFill>
+                            <a:srgbClr val="0F172A"/>
+                          </a:solidFill>
+                        </a:defRPr>
+                      </a:pPr>
+                      <a:r>
+                        <a:t>  - Idle Interest (5% p.a.)</a:t>
+                      </a:r>
+                    </a:p>
+                  </a:txBody>
+                  <a:tcPr>
+                    <a:solidFill>
+                      <a:srgbClr val="F1F5F9"/>
+                    </a:solidFill>
+                  </a:tcPr>
+                </a:tc>
+                <a:tc>
+                  <a:txBody>
+                    <a:bodyPr/>
+                    <a:lstStyle/>
+                    <a:p>
+                      <a:pPr algn="ctr">
+                        <a:defRPr sz="850">
+                          <a:solidFill>
+                            <a:srgbClr val="0F172A"/>
+                          </a:solidFill>
+                        </a:defRPr>
+                      </a:pPr>
+                      <a:r>
+                        <a:t>Rs. 4.24 Lakhs</a:t>
+                      </a:r>
+                    </a:p>
+                  </a:txBody>
+                  <a:tcPr>
+                    <a:solidFill>
+                      <a:srgbClr val="F1F5F9"/>
+                    </a:solidFill>
+                  </a:tcPr>
+                </a:tc>
+                <a:tc>
+                  <a:txBody>
+                    <a:bodyPr/>
+                    <a:lstStyle/>
+                    <a:p>
+                      <a:pPr algn="ctr">
+                        <a:defRPr sz="850" b="1">
+                          <a:solidFill>
+                            <a:srgbClr val="059669"/>
+                          </a:solidFill>
+                        </a:defRPr>
+                      </a:pPr>
+                      <a:r>
+                        <a:t>Rs. 9.52 Lakhs</a:t>
+                      </a:r>
+                    </a:p>
+                  </a:txBody>
+                  <a:tcPr>
+                    <a:solidFill>
+                      <a:srgbClr val="F1F5F9"/>
+                    </a:solidFill>
+                  </a:tcPr>
+                </a:tc>
+                <a:tc>
+                  <a:txBody>
+                    <a:bodyPr/>
+                    <a:lstStyle/>
+                    <a:p>
+                      <a:pPr algn="ctr">
+                        <a:defRPr sz="850" b="1">
+                          <a:solidFill>
+                            <a:srgbClr val="7C3AED"/>
+                          </a:solidFill>
+                        </a:defRPr>
+                      </a:pPr>
+                      <a:r>
+                        <a:t>+Rs. 5.28L on Buffer</a:t>
+                      </a:r>
+                    </a:p>
+                  </a:txBody>
+                  <a:tcPr>
+                    <a:solidFill>
+                      <a:srgbClr val="F1F5F9"/>
+                    </a:solidFill>
+                  </a:tcPr>
+                </a:tc>
+              </a:tr>
+              <a:tr h="359228">
+                <a:tc>
+                  <a:txBody>
+                    <a:bodyPr/>
+                    <a:lstStyle/>
+                    <a:p>
+                      <a:pPr algn="l">
+                        <a:defRPr sz="850">
+                          <a:solidFill>
+                            <a:srgbClr val="0F172A"/>
+                          </a:solidFill>
+                        </a:defRPr>
+                      </a:pPr>
+                      <a:r>
+                        <a:t>  - Dividend Income</a:t>
+                      </a:r>
+                    </a:p>
+                  </a:txBody>
+                  <a:tcPr>
+                    <a:solidFill>
+                      <a:srgbClr val="FFFFFF"/>
+                    </a:solidFill>
+                  </a:tcPr>
+                </a:tc>
+                <a:tc>
+                  <a:txBody>
+                    <a:bodyPr/>
+                    <a:lstStyle/>
+                    <a:p>
+                      <a:pPr algn="ctr">
+                        <a:defRPr sz="850">
+                          <a:solidFill>
+                            <a:srgbClr val="0F172A"/>
+                          </a:solidFill>
+                        </a:defRPr>
+                      </a:pPr>
+                      <a:r>
+                        <a:t>Rs. 1.30 Lakhs</a:t>
+                      </a:r>
+                    </a:p>
+                  </a:txBody>
+                  <a:tcPr>
+                    <a:solidFill>
+                      <a:srgbClr val="FFFFFF"/>
+                    </a:solidFill>
+                  </a:tcPr>
+                </a:tc>
+                <a:tc>
+                  <a:txBody>
+                    <a:bodyPr/>
+                    <a:lstStyle/>
+                    <a:p>
+                      <a:pPr algn="ctr">
+                        <a:defRPr sz="850" b="1">
+                          <a:solidFill>
+                            <a:srgbClr val="059669"/>
+                          </a:solidFill>
+                        </a:defRPr>
+                      </a:pPr>
+                      <a:r>
+                        <a:t>Rs. 2.80 Lakhs</a:t>
+                      </a:r>
+                    </a:p>
+                  </a:txBody>
+                  <a:tcPr>
+                    <a:solidFill>
+                      <a:srgbClr val="FFFFFF"/>
+                    </a:solidFill>
+                  </a:tcPr>
+                </a:tc>
+                <a:tc>
+                  <a:txBody>
+                    <a:bodyPr/>
+                    <a:lstStyle/>
+                    <a:p>
+                      <a:pPr algn="ctr">
+                        <a:defRPr sz="850" b="1">
+                          <a:solidFill>
+                            <a:srgbClr val="7C3AED"/>
+                          </a:solidFill>
+                        </a:defRPr>
+                      </a:pPr>
+                      <a:r>
+                        <a:t>+Rs. 1.50L Dividends</a:t>
+                      </a:r>
+                    </a:p>
+                  </a:txBody>
+                  <a:tcPr>
+                    <a:solidFill>
+                      <a:srgbClr val="FFFFFF"/>
+                    </a:solidFill>
+                  </a:tcPr>
+                </a:tc>
+              </a:tr>
+              <a:tr h="359228">
+                <a:tc>
+                  <a:txBody>
+                    <a:bodyPr/>
+                    <a:lstStyle/>
+                    <a:p>
+                      <a:pPr algn="l">
+                        <a:defRPr sz="850">
+                          <a:solidFill>
+                            <a:srgbClr val="0F172A"/>
+                          </a:solidFill>
+                        </a:defRPr>
+                      </a:pPr>
+                      <a:r>
+                        <a:t>Unrealized Open P&amp;L</a:t>
+                      </a:r>
+                    </a:p>
+                  </a:txBody>
+                  <a:tcPr>
+                    <a:solidFill>
+                      <a:srgbClr val="F1F5F9"/>
+                    </a:solidFill>
+                  </a:tcPr>
+                </a:tc>
+                <a:tc>
+                  <a:txBody>
+                    <a:bodyPr/>
+                    <a:lstStyle/>
+                    <a:p>
+                      <a:pPr algn="ctr">
+                        <a:defRPr sz="850">
+                          <a:solidFill>
+                            <a:srgbClr val="0F172A"/>
+                          </a:solidFill>
+                        </a:defRPr>
+                      </a:pPr>
+                      <a:r>
+                        <a:t>+Rs. 67,842</a:t>
+                      </a:r>
+                    </a:p>
+                  </a:txBody>
+                  <a:tcPr>
+                    <a:solidFill>
+                      <a:srgbClr val="F1F5F9"/>
+                    </a:solidFill>
+                  </a:tcPr>
+                </a:tc>
+                <a:tc>
+                  <a:txBody>
+                    <a:bodyPr/>
+                    <a:lstStyle/>
+                    <a:p>
+                      <a:pPr algn="ctr">
+                        <a:defRPr sz="850" b="1">
+                          <a:solidFill>
+                            <a:srgbClr val="0F172A"/>
+                          </a:solidFill>
+                        </a:defRPr>
+                      </a:pPr>
+                      <a:r>
+                        <a:t>-Rs. 2,85,244</a:t>
+                      </a:r>
+                    </a:p>
+                  </a:txBody>
+                  <a:tcPr>
+                    <a:solidFill>
+                      <a:srgbClr val="F1F5F9"/>
+                    </a:solidFill>
+                  </a:tcPr>
+                </a:tc>
+                <a:tc>
+                  <a:txBody>
+                    <a:bodyPr/>
+                    <a:lstStyle/>
+                    <a:p>
+                      <a:pPr algn="ctr">
+                        <a:defRPr sz="850" b="1">
+                          <a:solidFill>
+                            <a:srgbClr val="7C3AED"/>
+                          </a:solidFill>
+                        </a:defRPr>
+                      </a:pPr>
+                      <a:r>
+                        <a:t>+Rs. 3.53L Cushion</a:t>
+                      </a:r>
+                    </a:p>
+                  </a:txBody>
+                  <a:tcPr>
+                    <a:solidFill>
+                      <a:srgbClr val="F1F5F9"/>
+                    </a:solidFill>
+                  </a:tcPr>
+                </a:tc>
+              </a:tr>
+              <a:tr h="359228">
+                <a:tc>
+                  <a:txBody>
+                    <a:bodyPr/>
+                    <a:lstStyle/>
+                    <a:p>
+                      <a:pPr algn="l">
+                        <a:defRPr sz="850">
+                          <a:solidFill>
+                            <a:srgbClr val="0F172A"/>
+                          </a:solidFill>
+                        </a:defRPr>
+                      </a:pPr>
+                      <a:r>
+                        <a:t>Trades (Closed / Total)</a:t>
+                      </a:r>
+                    </a:p>
+                  </a:txBody>
+                  <a:tcPr>
+                    <a:solidFill>
+                      <a:srgbClr val="FFFFFF"/>
+                    </a:solidFill>
+                  </a:tcPr>
+                </a:tc>
+                <a:tc>
+                  <a:txBody>
+                    <a:bodyPr/>
+                    <a:lstStyle/>
+                    <a:p>
+                      <a:pPr algn="ctr">
+                        <a:defRPr sz="850">
+                          <a:solidFill>
+                            <a:srgbClr val="0F172A"/>
+                          </a:solidFill>
+                        </a:defRPr>
+                      </a:pPr>
+                      <a:r>
+                        <a:t>169 / 212</a:t>
+                      </a:r>
+                    </a:p>
+                  </a:txBody>
+                  <a:tcPr>
+                    <a:solidFill>
+                      <a:srgbClr val="FFFFFF"/>
+                    </a:solidFill>
+                  </a:tcPr>
+                </a:tc>
+                <a:tc>
+                  <a:txBody>
+                    <a:bodyPr/>
+                    <a:lstStyle/>
+                    <a:p>
+                      <a:pPr algn="ctr">
+                        <a:defRPr sz="850" b="1">
+                          <a:solidFill>
+                            <a:srgbClr val="0F172A"/>
+                          </a:solidFill>
+                        </a:defRPr>
+                      </a:pPr>
+                      <a:r>
+                        <a:t>1,109 / 1,218</a:t>
+                      </a:r>
+                    </a:p>
+                  </a:txBody>
+                  <a:tcPr>
+                    <a:solidFill>
+                      <a:srgbClr val="FFFFFF"/>
+                    </a:solidFill>
+                  </a:tcPr>
+                </a:tc>
+                <a:tc>
+                  <a:txBody>
+                    <a:bodyPr/>
+                    <a:lstStyle/>
+                    <a:p>
+                      <a:pPr algn="ctr">
+                        <a:defRPr sz="850" b="1">
+                          <a:solidFill>
+                            <a:srgbClr val="7C3AED"/>
+                          </a:solidFill>
+                        </a:defRPr>
+                      </a:pPr>
+                      <a:r>
+                        <a:t>-82.6% Trades Filtered</a:t>
+                      </a:r>
+                    </a:p>
+                  </a:txBody>
+                  <a:tcPr>
+                    <a:solidFill>
+                      <a:srgbClr val="FFFFFF"/>
+                    </a:solidFill>
+                  </a:tcPr>
+                </a:tc>
+              </a:tr>
+              <a:tr h="359228">
+                <a:tc>
+                  <a:txBody>
+                    <a:bodyPr/>
+                    <a:lstStyle/>
+                    <a:p>
+                      <a:pPr algn="l">
+                        <a:defRPr sz="850">
+                          <a:solidFill>
+                            <a:srgbClr val="0F172A"/>
+                          </a:solidFill>
+                        </a:defRPr>
+                      </a:pPr>
+                      <a:r>
+                        <a:t>  - Bearish Dip Tranches</a:t>
+                      </a:r>
+                    </a:p>
+                  </a:txBody>
+                  <a:tcPr>
+                    <a:solidFill>
+                      <a:srgbClr val="F1F5F9"/>
+                    </a:solidFill>
+                  </a:tcPr>
+                </a:tc>
+                <a:tc>
+                  <a:txBody>
+                    <a:bodyPr/>
+                    <a:lstStyle/>
+                    <a:p>
+                      <a:pPr algn="ctr">
+                        <a:defRPr sz="850">
+                          <a:solidFill>
+                            <a:srgbClr val="0F172A"/>
+                          </a:solidFill>
+                        </a:defRPr>
+                      </a:pPr>
+                      <a:r>
+                        <a:t>128 trades</a:t>
+                      </a:r>
+                    </a:p>
+                  </a:txBody>
+                  <a:tcPr>
+                    <a:solidFill>
+                      <a:srgbClr val="F1F5F9"/>
+                    </a:solidFill>
+                  </a:tcPr>
+                </a:tc>
+                <a:tc>
+                  <a:txBody>
+                    <a:bodyPr/>
+                    <a:lstStyle/>
+                    <a:p>
+                      <a:pPr algn="ctr">
+                        <a:defRPr sz="850" b="1">
+                          <a:solidFill>
+                            <a:srgbClr val="0F172A"/>
+                          </a:solidFill>
+                        </a:defRPr>
+                      </a:pPr>
+                      <a:r>
+                        <a:t>1,107 trades</a:t>
+                      </a:r>
+                    </a:p>
+                  </a:txBody>
+                  <a:tcPr>
+                    <a:solidFill>
+                      <a:srgbClr val="F1F5F9"/>
+                    </a:solidFill>
+                  </a:tcPr>
+                </a:tc>
+                <a:tc>
+                  <a:txBody>
+                    <a:bodyPr/>
+                    <a:lstStyle/>
+                    <a:p>
+                      <a:pPr algn="ctr">
+                        <a:defRPr sz="850" b="1">
+                          <a:solidFill>
+                            <a:srgbClr val="7C3AED"/>
+                          </a:solidFill>
+                        </a:defRPr>
+                      </a:pPr>
+                      <a:r>
+                        <a:t>-979 Bounces Skipped</a:t>
+                      </a:r>
+                    </a:p>
+                  </a:txBody>
+                  <a:tcPr>
+                    <a:solidFill>
+                      <a:srgbClr val="F1F5F9"/>
+                    </a:solidFill>
+                  </a:tcPr>
+                </a:tc>
+              </a:tr>
+              <a:tr h="359228">
+                <a:tc>
+                  <a:txBody>
+                    <a:bodyPr/>
+                    <a:lstStyle/>
+                    <a:p>
+                      <a:pPr algn="l">
+                        <a:defRPr sz="850">
+                          <a:solidFill>
+                            <a:srgbClr val="0F172A"/>
+                          </a:solidFill>
+                        </a:defRPr>
+                      </a:pPr>
+                      <a:r>
+                        <a:t>Deployed XIRR %</a:t>
+                      </a:r>
+                    </a:p>
+                  </a:txBody>
+                  <a:tcPr>
+                    <a:solidFill>
+                      <a:srgbClr val="FFFFFF"/>
+                    </a:solidFill>
+                  </a:tcPr>
+                </a:tc>
+                <a:tc>
+                  <a:txBody>
+                    <a:bodyPr/>
+                    <a:lstStyle/>
+                    <a:p>
+                      <a:pPr algn="ctr">
+                        <a:defRPr sz="850">
+                          <a:solidFill>
+                            <a:srgbClr val="0F172A"/>
+                          </a:solidFill>
+                        </a:defRPr>
+                      </a:pPr>
+                      <a:r>
+                        <a:t>28.72% p.a.</a:t>
+                      </a:r>
+                    </a:p>
+                  </a:txBody>
+                  <a:tcPr>
+                    <a:solidFill>
+                      <a:srgbClr val="FFFFFF"/>
+                    </a:solidFill>
+                  </a:tcPr>
+                </a:tc>
+                <a:tc>
+                  <a:txBody>
+                    <a:bodyPr/>
+                    <a:lstStyle/>
+                    <a:p>
+                      <a:pPr algn="ctr">
+                        <a:defRPr sz="850" b="1">
+                          <a:solidFill>
+                            <a:srgbClr val="059669"/>
+                          </a:solidFill>
+                        </a:defRPr>
+                      </a:pPr>
+                      <a:r>
+                        <a:t>28.05% p.a.</a:t>
+                      </a:r>
+                    </a:p>
+                  </a:txBody>
+                  <a:tcPr>
+                    <a:solidFill>
+                      <a:srgbClr val="FFFFFF"/>
+                    </a:solidFill>
+                  </a:tcPr>
+                </a:tc>
+                <a:tc>
+                  <a:txBody>
+                    <a:bodyPr/>
+                    <a:lstStyle/>
+                    <a:p>
+                      <a:pPr algn="ctr">
+                        <a:defRPr sz="850" b="1">
+                          <a:solidFill>
+                            <a:srgbClr val="7C3AED"/>
+                          </a:solidFill>
+                        </a:defRPr>
+                      </a:pPr>
+                      <a:r>
+                        <a:t>Equal Velocity (~28%)</a:t>
+                      </a:r>
+                    </a:p>
+                  </a:txBody>
+                  <a:tcPr>
+                    <a:solidFill>
+                      <a:srgbClr val="FFFFFF"/>
+                    </a:solidFill>
+                  </a:tcPr>
+                </a:tc>
+              </a:tr>
+              <a:tr h="359228">
+                <a:tc>
+                  <a:txBody>
+                    <a:bodyPr/>
+                    <a:lstStyle/>
+                    <a:p>
+                      <a:pPr algn="l">
+                        <a:defRPr sz="850">
+                          <a:solidFill>
+                            <a:srgbClr val="0F172A"/>
+                          </a:solidFill>
+                        </a:defRPr>
+                      </a:pPr>
+                      <a:r>
+                        <a:t>Portfolio XIRR %</a:t>
+                      </a:r>
+                    </a:p>
+                  </a:txBody>
+                  <a:tcPr>
+                    <a:solidFill>
+                      <a:srgbClr val="F1F5F9"/>
+                    </a:solidFill>
+                  </a:tcPr>
+                </a:tc>
+                <a:tc>
+                  <a:txBody>
+                    <a:bodyPr/>
+                    <a:lstStyle/>
+                    <a:p>
+                      <a:pPr algn="ctr">
+                        <a:defRPr sz="850">
+                          <a:solidFill>
+                            <a:srgbClr val="0F172A"/>
+                          </a:solidFill>
+                        </a:defRPr>
+                      </a:pPr>
+                      <a:r>
+                        <a:t>5.39% p.a.</a:t>
+                      </a:r>
+                    </a:p>
+                  </a:txBody>
+                  <a:tcPr>
+                    <a:solidFill>
+                      <a:srgbClr val="F1F5F9"/>
+                    </a:solidFill>
+                  </a:tcPr>
+                </a:tc>
+                <a:tc>
+                  <a:txBody>
+                    <a:bodyPr/>
+                    <a:lstStyle/>
+                    <a:p>
+                      <a:pPr algn="ctr">
+                        <a:defRPr sz="850" b="1">
+                          <a:solidFill>
+                            <a:srgbClr val="059669"/>
+                          </a:solidFill>
+                        </a:defRPr>
+                      </a:pPr>
+                      <a:r>
+                        <a:t>9.51% p.a.</a:t>
+                      </a:r>
+                    </a:p>
+                  </a:txBody>
+                  <a:tcPr>
+                    <a:solidFill>
+                      <a:srgbClr val="F1F5F9"/>
+                    </a:solidFill>
+                  </a:tcPr>
+                </a:tc>
+                <a:tc>
+                  <a:txBody>
+                    <a:bodyPr/>
+                    <a:lstStyle/>
+                    <a:p>
+                      <a:pPr algn="ctr">
+                        <a:defRPr sz="850" b="1">
+                          <a:solidFill>
+                            <a:srgbClr val="7C3AED"/>
+                          </a:solidFill>
+                        </a:defRPr>
+                      </a:pPr>
+                      <a:r>
+                        <a:t>+4.12% p.a. on Cash</a:t>
+                      </a:r>
+                    </a:p>
+                  </a:txBody>
+                  <a:tcPr>
+                    <a:solidFill>
+                      <a:srgbClr val="F1F5F9"/>
+                    </a:solidFill>
+                  </a:tcPr>
+                </a:tc>
+              </a:tr>
+              <a:tr h="359228">
+                <a:tc>
+                  <a:txBody>
+                    <a:bodyPr/>
+                    <a:lstStyle/>
+                    <a:p>
+                      <a:pPr algn="l">
+                        <a:defRPr sz="850">
+                          <a:solidFill>
+                            <a:srgbClr val="0F172A"/>
+                          </a:solidFill>
+                        </a:defRPr>
+                      </a:pPr>
+                      <a:r>
+                        <a:t>Max Drawdown %</a:t>
+                      </a:r>
+                    </a:p>
+                  </a:txBody>
+                  <a:tcPr>
+                    <a:solidFill>
+                      <a:srgbClr val="FFFFFF"/>
+                    </a:solidFill>
+                  </a:tcPr>
+                </a:tc>
+                <a:tc>
+                  <a:txBody>
+                    <a:bodyPr/>
+                    <a:lstStyle/>
+                    <a:p>
+                      <a:pPr algn="ctr">
+                        <a:defRPr sz="850">
+                          <a:solidFill>
+                            <a:srgbClr val="0F172A"/>
+                          </a:solidFill>
+                        </a:defRPr>
+                      </a:pPr>
+                      <a:r>
+                        <a:t>4.92%</a:t>
+                      </a:r>
+                    </a:p>
+                  </a:txBody>
+                  <a:tcPr>
+                    <a:solidFill>
+                      <a:srgbClr val="FFFFFF"/>
+                    </a:solidFill>
+                  </a:tcPr>
+                </a:tc>
+                <a:tc>
+                  <a:txBody>
+                    <a:bodyPr/>
+                    <a:lstStyle/>
+                    <a:p>
+                      <a:pPr algn="ctr">
+                        <a:defRPr sz="850" b="1">
+                          <a:solidFill>
+                            <a:srgbClr val="059669"/>
+                          </a:solidFill>
+                        </a:defRPr>
+                      </a:pPr>
+                      <a:r>
+                        <a:t>5.27%</a:t>
+                      </a:r>
+                    </a:p>
+                  </a:txBody>
+                  <a:tcPr>
+                    <a:solidFill>
+                      <a:srgbClr val="FFFFFF"/>
+                    </a:solidFill>
+                  </a:tcPr>
+                </a:tc>
+                <a:tc>
+                  <a:txBody>
+                    <a:bodyPr/>
+                    <a:lstStyle/>
+                    <a:p>
+                      <a:pPr algn="ctr">
+                        <a:defRPr sz="850" b="1">
+                          <a:solidFill>
+                            <a:srgbClr val="7C3AED"/>
+                          </a:solidFill>
+                        </a:defRPr>
+                      </a:pPr>
+                      <a:r>
+                        <a:t>Only 0.35% Difference</a:t>
+                      </a:r>
+                    </a:p>
+                  </a:txBody>
+                  <a:tcPr>
+                    <a:solidFill>
+                      <a:srgbClr val="FFFFFF"/>
+                    </a:solidFill>
+                  </a:tcPr>
+                </a:tc>
+              </a:tr>
+              <a:tr h="359236">
+                <a:tc>
+                  <a:txBody>
+                    <a:bodyPr/>
+                    <a:lstStyle/>
+                    <a:p>
+                      <a:pPr algn="l">
+                        <a:defRPr sz="850">
+                          <a:solidFill>
+                            <a:srgbClr val="0F172A"/>
+                          </a:solidFill>
+                        </a:defRPr>
+                      </a:pPr>
+                      <a:r>
+                        <a:t>Ending Overall Capital</a:t>
+                      </a:r>
+                    </a:p>
+                  </a:txBody>
+                  <a:tcPr>
+                    <a:solidFill>
+                      <a:srgbClr val="F1F5F9"/>
+                    </a:solidFill>
+                  </a:tcPr>
+                </a:tc>
+                <a:tc>
+                  <a:txBody>
+                    <a:bodyPr/>
+                    <a:lstStyle/>
+                    <a:p>
+                      <a:pPr algn="ctr">
+                        <a:defRPr sz="850">
+                          <a:solidFill>
+                            <a:srgbClr val="0F172A"/>
+                          </a:solidFill>
+                        </a:defRPr>
+                      </a:pPr>
+                      <a:r>
+                        <a:t>Rs. 70.72 Lakhs</a:t>
+                      </a:r>
+                    </a:p>
+                  </a:txBody>
+                  <a:tcPr>
+                    <a:solidFill>
+                      <a:srgbClr val="F1F5F9"/>
+                    </a:solidFill>
+                  </a:tcPr>
+                </a:tc>
+                <a:tc>
+                  <a:txBody>
+                    <a:bodyPr/>
+                    <a:lstStyle/>
+                    <a:p>
+                      <a:pPr algn="ctr">
+                        <a:defRPr sz="850" b="1">
+                          <a:solidFill>
+                            <a:srgbClr val="059669"/>
+                          </a:solidFill>
+                        </a:defRPr>
+                      </a:pPr>
+                      <a:r>
+                        <a:t>Rs. 95.53 Lakhs</a:t>
+                      </a:r>
+                    </a:p>
+                  </a:txBody>
+                  <a:tcPr>
+                    <a:solidFill>
+                      <a:srgbClr val="F1F5F9"/>
+                    </a:solidFill>
+                  </a:tcPr>
+                </a:tc>
+                <a:tc>
+                  <a:txBody>
+                    <a:bodyPr/>
+                    <a:lstStyle/>
+                    <a:p>
+                      <a:pPr algn="ctr">
+                        <a:defRPr sz="850" b="1">
+                          <a:solidFill>
+                            <a:srgbClr val="7C3AED"/>
+                          </a:solidFill>
+                        </a:defRPr>
+                      </a:pPr>
+                      <a:r>
+                        <a:t>+Rs. 24.81L Wealth Gap</a:t>
+                      </a:r>
+                    </a:p>
+                  </a:txBody>
+                  <a:tcPr>
+                    <a:solidFill>
+                      <a:srgbClr val="F1F5F9"/>
+                    </a:solidFill>
+                  </a:tcPr>
+                </a:tc>
+              </a:tr>
+            </a:tbl>
+          </a:graphicData>
+        </a:graphic>
+      </p:graphicFrame>
+      <p:pic>
+        <p:nvPicPr>
+          <p:cNvPr id="6" name="Picture 5" descr="deck_equity_journey.png"/>
+          <p:cNvPicPr>
+            <a:picLocks noChangeAspect="1"/>
+          </p:cNvPicPr>
+          <p:nvPr/>
+        </p:nvPicPr>
+        <p:blipFill>
+          <a:blip r:embed="rId2"/>
+          <a:stretch>
+            <a:fillRect/>
+          </a:stretch>
+        </p:blipFill>
+        <p:spPr>
+          <a:xfrm>
+            <a:off x="7452360" y="1417320"/>
+            <a:ext cx="4005072" cy="3337560"/>
+          </a:xfrm>
+          <a:prstGeom prst="rect">
+            <a:avLst/>
+          </a:prstGeom>
+        </p:spPr>
+      </p:pic>
+      <p:sp>
+        <p:nvSpPr>
+          <p:cNvPr id="7" name="Rounded Rectangle 6"/>
+          <p:cNvSpPr/>
+          <p:nvPr/>
+        </p:nvSpPr>
+        <p:spPr>
+          <a:xfrm>
+            <a:off x="7452360" y="4892040"/>
+            <a:ext cx="4005072" cy="1554480"/>
+          </a:xfrm>
+          <a:prstGeom prst="roundRect">
+            <a:avLst/>
+          </a:prstGeom>
+          <a:solidFill>
+            <a:srgbClr val="ECFDF5"/>
+          </a:solidFill>
+          <a:ln w="12700">
+            <a:solidFill>
+              <a:srgbClr val="059669"/>
+            </a:solidFill>
+          </a:ln>
+        </p:spPr>
+        <p:style>
+          <a:lnRef idx="1">
+            <a:schemeClr val="accent1"/>
+          </a:lnRef>
+          <a:fillRef idx="3">
+            <a:schemeClr val="accent1"/>
+          </a:fillRef>
+          <a:effectRef idx="2">
+            <a:schemeClr val="accent1"/>
+          </a:effectRef>
+          <a:fontRef idx="minor">
+            <a:schemeClr val="lt1"/>
+          </a:fontRef>
+        </p:style>
+        <p:txBody>
+          <a:bodyPr rtlCol="0" anchor="ctr"/>
+          <a:lstStyle/>
+          <a:p>
+            <a:pPr algn="ctr"/>
+          </a:p>
+        </p:txBody>
+      </p:sp>
+      <p:sp>
+        <p:nvSpPr>
+          <p:cNvPr id="8" name="TextBox 7"/>
+          <p:cNvSpPr txBox="1"/>
+          <p:nvPr/>
+        </p:nvSpPr>
+        <p:spPr>
+          <a:xfrm>
+            <a:off x="7543800" y="4956048"/>
+            <a:ext cx="3822191" cy="1417320"/>
+          </a:xfrm>
+          <a:prstGeom prst="rect">
+            <a:avLst/>
+          </a:prstGeom>
+          <a:noFill/>
+        </p:spPr>
+        <p:txBody>
+          <a:bodyPr wrap="square" lIns="0" rIns="0" tIns="0" bIns="0">
+            <a:spAutoFit/>
+          </a:bodyPr>
+          <a:lstStyle/>
+          <a:p>
+            <a:pPr>
+              <a:defRPr sz="1000" b="1">
+                <a:solidFill>
+                  <a:srgbClr val="059669"/>
+                </a:solidFill>
+              </a:defRPr>
+            </a:pPr>
+            <a:r>
+              <a:t>EXECUTIVE TAKEAWAY FROM THE DATA</a:t>
+            </a:r>
+          </a:p>
+          <a:p>
+            <a:pPr>
+              <a:defRPr sz="850">
+                <a:solidFill>
+                  <a:srgbClr val="0F172A"/>
+                </a:solidFill>
+              </a:defRPr>
+            </a:pPr>
+            <a:r>
+              <a:t>• Baseline generates 2x the profit: +Rs. 42.67L (+85.4%) vs +Rs. 21.40L (+42.8%).</a:t>
+            </a:r>
+            <a:br/>
+            <a:r>
+              <a:t>• Banked cash difference is massive: +Rs. 24.81 Lakhs extra realized cash.</a:t>
+            </a:r>
+            <a:br/>
+            <a:r>
+              <a:t>• The -Rs. 2.85L open dip is minor: Easily absorbed by +Rs. 24.81L cash cushion.</a:t>
+            </a:r>
+          </a:p>
+        </p:txBody>
+      </p:sp>
+    </p:spTree>
+  </p:cSld>
+  <p:clrMapOvr>
+    <a:masterClrMapping/>
+  </p:clrMapOvr>
+</p:sld>
+</file>
+
+<file path=ppt/slides/slide12.xml><?xml version="1.0" encoding="utf-8"?>
+<p:sld xmlns:a="http://schemas.openxmlformats.org/drawingml/2006/main" xmlns:p="http://schemas.openxmlformats.org/presentationml/2006/main" xmlns:r="http://schemas.openxmlformats.org/officeDocument/2006/relationships">
+  <p:cSld>
+    <p:spTree>
+      <p:nvGrpSpPr>
+        <p:cNvPr id="1" name=""/>
+        <p:cNvGrpSpPr/>
+        <p:nvPr/>
+      </p:nvGrpSpPr>
+      <p:grpSpPr/>
+      <p:sp>
+        <p:nvSpPr>
+          <p:cNvPr id="2" name="Rectangle 1"/>
+          <p:cNvSpPr/>
+          <p:nvPr/>
+        </p:nvSpPr>
+        <p:spPr>
+          <a:xfrm>
+            <a:off x="0" y="0"/>
+            <a:ext cx="12191695" cy="6858000"/>
+          </a:xfrm>
+          <a:prstGeom prst="rect">
+            <a:avLst/>
+          </a:prstGeom>
+          <a:solidFill>
+            <a:srgbClr val="F8FAFC"/>
+          </a:solidFill>
+          <a:ln>
+            <a:solidFill>
+              <a:srgbClr val="F8FAFC"/>
+            </a:solidFill>
+          </a:ln>
+        </p:spPr>
+        <p:style>
+          <a:lnRef idx="1">
+            <a:schemeClr val="accent1"/>
+          </a:lnRef>
+          <a:fillRef idx="3">
+            <a:schemeClr val="accent1"/>
+          </a:fillRef>
+          <a:effectRef idx="2">
+            <a:schemeClr val="accent1"/>
+          </a:effectRef>
+          <a:fontRef idx="minor">
+            <a:schemeClr val="lt1"/>
+          </a:fontRef>
+        </p:style>
+        <p:txBody>
+          <a:bodyPr rtlCol="0" anchor="ctr"/>
+          <a:lstStyle/>
+          <a:p>
+            <a:pPr algn="ctr"/>
+          </a:p>
+        </p:txBody>
+      </p:sp>
+      <p:sp>
+        <p:nvSpPr>
+          <p:cNvPr id="3" name="TextBox 2"/>
+          <p:cNvSpPr txBox="1"/>
+          <p:nvPr/>
+        </p:nvSpPr>
+        <p:spPr>
+          <a:xfrm>
+            <a:off x="731520" y="365760"/>
+            <a:ext cx="10698480" cy="822960"/>
+          </a:xfrm>
+          <a:prstGeom prst="rect">
+            <a:avLst/>
+          </a:prstGeom>
+          <a:noFill/>
+        </p:spPr>
+        <p:txBody>
+          <a:bodyPr wrap="square" lIns="0" tIns="0" rIns="0" bIns="0">
+            <a:spAutoFit/>
+          </a:bodyPr>
+          <a:lstStyle/>
+          <a:p>
+            <a:pPr>
+              <a:defRPr sz="1000" b="1">
+                <a:solidFill>
+                  <a:srgbClr val="2563EB"/>
+                </a:solidFill>
+              </a:defRPr>
+            </a:pPr>
+            <a:r>
+              <a:t>EXECUTIVE AT-A-GLANCE SUMMARY</a:t>
+            </a:r>
+          </a:p>
+          <a:p>
+            <a:pPr>
+              <a:defRPr sz="2200" b="1">
+                <a:solidFill>
+                  <a:srgbClr val="0F172A"/>
+                </a:solidFill>
+              </a:defRPr>
+            </a:pPr>
+            <a:r>
+              <a:t>The Essential Comparison: 3 Numbers That Settle the Debate</a:t>
+            </a:r>
+          </a:p>
+        </p:txBody>
+      </p:sp>
+      <p:sp>
+        <p:nvSpPr>
+          <p:cNvPr id="4" name="Rectangle 3"/>
+          <p:cNvSpPr/>
+          <p:nvPr/>
+        </p:nvSpPr>
+        <p:spPr>
+          <a:xfrm>
+            <a:off x="731520" y="1234440"/>
+            <a:ext cx="10728655" cy="18288"/>
+          </a:xfrm>
+          <a:prstGeom prst="rect">
+            <a:avLst/>
+          </a:prstGeom>
+          <a:solidFill>
+            <a:srgbClr val="E2E8F0"/>
+          </a:solidFill>
+          <a:ln>
+            <a:solidFill>
+              <a:srgbClr val="E2E8F0"/>
+            </a:solidFill>
+          </a:ln>
+        </p:spPr>
+        <p:style>
+          <a:lnRef idx="1">
+            <a:schemeClr val="accent1"/>
+          </a:lnRef>
+          <a:fillRef idx="3">
+            <a:schemeClr val="accent1"/>
+          </a:fillRef>
+          <a:effectRef idx="2">
+            <a:schemeClr val="accent1"/>
+          </a:effectRef>
+          <a:fontRef idx="minor">
+            <a:schemeClr val="lt1"/>
+          </a:fontRef>
+        </p:style>
+        <p:txBody>
+          <a:bodyPr rtlCol="0" anchor="ctr"/>
+          <a:lstStyle/>
+          <a:p>
+            <a:pPr algn="ctr"/>
+          </a:p>
+        </p:txBody>
+      </p:sp>
+      <p:sp>
+        <p:nvSpPr>
+          <p:cNvPr id="5" name="Rounded Rectangle 4"/>
+          <p:cNvSpPr/>
+          <p:nvPr/>
+        </p:nvSpPr>
+        <p:spPr>
+          <a:xfrm>
+            <a:off x="731520" y="1417320"/>
+            <a:ext cx="3383280" cy="2011680"/>
+          </a:xfrm>
+          <a:prstGeom prst="roundRect">
+            <a:avLst/>
+          </a:prstGeom>
+          <a:solidFill>
+            <a:srgbClr val="ECFDF5"/>
+          </a:solidFill>
+          <a:ln w="12700">
+            <a:solidFill>
+              <a:srgbClr val="059669"/>
+            </a:solidFill>
+          </a:ln>
+        </p:spPr>
+        <p:style>
+          <a:lnRef idx="1">
+            <a:schemeClr val="accent1"/>
+          </a:lnRef>
+          <a:fillRef idx="3">
+            <a:schemeClr val="accent1"/>
+          </a:fillRef>
+          <a:effectRef idx="2">
+            <a:schemeClr val="accent1"/>
+          </a:effectRef>
+          <a:fontRef idx="minor">
+            <a:schemeClr val="lt1"/>
+          </a:fontRef>
+        </p:style>
+        <p:txBody>
+          <a:bodyPr rtlCol="0" anchor="ctr"/>
+          <a:lstStyle/>
+          <a:p>
+            <a:pPr algn="ctr"/>
+          </a:p>
+        </p:txBody>
+      </p:sp>
+      <p:sp>
+        <p:nvSpPr>
+          <p:cNvPr id="6" name="TextBox 5"/>
+          <p:cNvSpPr txBox="1"/>
+          <p:nvPr/>
+        </p:nvSpPr>
+        <p:spPr>
+          <a:xfrm>
+            <a:off x="896112" y="1536192"/>
+            <a:ext cx="3054096" cy="1783080"/>
+          </a:xfrm>
+          <a:prstGeom prst="rect">
+            <a:avLst/>
+          </a:prstGeom>
+          <a:noFill/>
+        </p:spPr>
+        <p:txBody>
+          <a:bodyPr wrap="square" lIns="0" rIns="0" tIns="0" bIns="0">
+            <a:spAutoFit/>
+          </a:bodyPr>
+          <a:lstStyle/>
+          <a:p>
+            <a:pPr>
+              <a:defRPr sz="950" b="1">
+                <a:solidFill>
+                  <a:srgbClr val="059669"/>
+                </a:solidFill>
+              </a:defRPr>
+            </a:pPr>
+            <a:r>
+              <a:t>1. TOTAL NET PROFIT GENERATED</a:t>
+            </a:r>
+          </a:p>
+          <a:p>
+            <a:pPr>
+              <a:defRPr sz="1200" b="1">
+                <a:solidFill>
+                  <a:srgbClr val="0F172A"/>
+                </a:solidFill>
+              </a:defRPr>
+            </a:pPr>
+            <a:r>
+              <a:t>Baseline: ₹42.67 Lakhs (+85.4%)</a:t>
+            </a:r>
+            <a:br/>
+            <a:r>
+              <a:t>With CAR: ₹21.40 Lakhs (+42.8%)</a:t>
+            </a:r>
+          </a:p>
+          <a:p>
+            <a:pPr>
+              <a:defRPr sz="1100" b="1">
+                <a:solidFill>
+                  <a:srgbClr val="059669"/>
+                </a:solidFill>
+              </a:defRPr>
+            </a:pPr>
+            <a:r>
+              <a:t>+₹21.28 LAKHS (+99.5% EXTRA)</a:t>
+            </a:r>
+          </a:p>
+          <a:p>
+            <a:pPr>
+              <a:defRPr sz="850">
+                <a:solidFill>
+                  <a:srgbClr val="64748B"/>
+                </a:solidFill>
+              </a:defRPr>
+            </a:pPr>
+            <a:r>
+              <a:t>Baseline produced exactly double the net wealth over 6.8 years.</a:t>
+            </a:r>
+          </a:p>
+        </p:txBody>
+      </p:sp>
+      <p:sp>
+        <p:nvSpPr>
+          <p:cNvPr id="7" name="Rounded Rectangle 6"/>
+          <p:cNvSpPr/>
+          <p:nvPr/>
+        </p:nvSpPr>
+        <p:spPr>
+          <a:xfrm>
+            <a:off x="4389120" y="1417320"/>
+            <a:ext cx="3383280" cy="2011680"/>
+          </a:xfrm>
+          <a:prstGeom prst="roundRect">
+            <a:avLst/>
+          </a:prstGeom>
+          <a:solidFill>
+            <a:srgbClr val="EFF6FF"/>
+          </a:solidFill>
+          <a:ln w="12700">
+            <a:solidFill>
+              <a:srgbClr val="2563EB"/>
+            </a:solidFill>
+          </a:ln>
+        </p:spPr>
+        <p:style>
+          <a:lnRef idx="1">
+            <a:schemeClr val="accent1"/>
+          </a:lnRef>
+          <a:fillRef idx="3">
+            <a:schemeClr val="accent1"/>
+          </a:fillRef>
+          <a:effectRef idx="2">
+            <a:schemeClr val="accent1"/>
+          </a:effectRef>
+          <a:fontRef idx="minor">
+            <a:schemeClr val="lt1"/>
+          </a:fontRef>
+        </p:style>
+        <p:txBody>
+          <a:bodyPr rtlCol="0" anchor="ctr"/>
+          <a:lstStyle/>
+          <a:p>
+            <a:pPr algn="ctr"/>
+          </a:p>
+        </p:txBody>
+      </p:sp>
+      <p:sp>
+        <p:nvSpPr>
+          <p:cNvPr id="8" name="TextBox 7"/>
+          <p:cNvSpPr txBox="1"/>
+          <p:nvPr/>
+        </p:nvSpPr>
+        <p:spPr>
+          <a:xfrm>
+            <a:off x="4553712" y="1536192"/>
+            <a:ext cx="3054096" cy="1783080"/>
+          </a:xfrm>
+          <a:prstGeom prst="rect">
+            <a:avLst/>
+          </a:prstGeom>
+          <a:noFill/>
+        </p:spPr>
+        <p:txBody>
+          <a:bodyPr wrap="square" lIns="0" rIns="0" tIns="0" bIns="0">
+            <a:spAutoFit/>
+          </a:bodyPr>
+          <a:lstStyle/>
+          <a:p>
+            <a:pPr>
+              <a:defRPr sz="950" b="1">
+                <a:solidFill>
+                  <a:srgbClr val="2563EB"/>
+                </a:solidFill>
+              </a:defRPr>
+            </a:pPr>
+            <a:r>
+              <a:t>2. REALIZED CASH IN HAND</a:t>
+            </a:r>
+          </a:p>
+          <a:p>
+            <a:pPr>
+              <a:defRPr sz="1200" b="1">
+                <a:solidFill>
+                  <a:srgbClr val="0F172A"/>
+                </a:solidFill>
+              </a:defRPr>
+            </a:pPr>
+            <a:r>
+              <a:t>Baseline: ₹45.53 Lakhs</a:t>
+            </a:r>
+            <a:br/>
+            <a:r>
+              <a:t>With CAR: ₹20.72 Lakhs</a:t>
+            </a:r>
+          </a:p>
+          <a:p>
+            <a:pPr>
+              <a:defRPr sz="1100" b="1">
+                <a:solidFill>
+                  <a:srgbClr val="2563EB"/>
+                </a:solidFill>
+              </a:defRPr>
+            </a:pPr>
+            <a:r>
+              <a:t>+₹24.81 LAKHS EXTRA CASH</a:t>
+            </a:r>
+          </a:p>
+          <a:p>
+            <a:pPr>
+              <a:defRPr sz="850">
+                <a:solidFill>
+                  <a:srgbClr val="64748B"/>
+                </a:solidFill>
+              </a:defRPr>
+            </a:pPr>
+            <a:r>
+              <a:t>Banked hard profit in your account dwarfing any floating dip.</a:t>
+            </a:r>
+          </a:p>
+        </p:txBody>
+      </p:sp>
+      <p:sp>
+        <p:nvSpPr>
+          <p:cNvPr id="9" name="Rounded Rectangle 8"/>
+          <p:cNvSpPr/>
+          <p:nvPr/>
+        </p:nvSpPr>
+        <p:spPr>
+          <a:xfrm>
+            <a:off x="8046720" y="1417320"/>
+            <a:ext cx="3383280" cy="2011680"/>
+          </a:xfrm>
+          <a:prstGeom prst="roundRect">
+            <a:avLst/>
+          </a:prstGeom>
+          <a:solidFill>
+            <a:srgbClr val="FEF3C7"/>
+          </a:solidFill>
+          <a:ln w="12700">
+            <a:solidFill>
+              <a:srgbClr val="D97706"/>
+            </a:solidFill>
+          </a:ln>
+        </p:spPr>
+        <p:style>
+          <a:lnRef idx="1">
+            <a:schemeClr val="accent1"/>
+          </a:lnRef>
+          <a:fillRef idx="3">
+            <a:schemeClr val="accent1"/>
+          </a:fillRef>
+          <a:effectRef idx="2">
+            <a:schemeClr val="accent1"/>
+          </a:effectRef>
+          <a:fontRef idx="minor">
+            <a:schemeClr val="lt1"/>
+          </a:fontRef>
+        </p:style>
+        <p:txBody>
+          <a:bodyPr rtlCol="0" anchor="ctr"/>
+          <a:lstStyle/>
+          <a:p>
+            <a:pPr algn="ctr"/>
+          </a:p>
+        </p:txBody>
+      </p:sp>
+      <p:sp>
+        <p:nvSpPr>
+          <p:cNvPr id="10" name="TextBox 9"/>
+          <p:cNvSpPr txBox="1"/>
+          <p:nvPr/>
+        </p:nvSpPr>
+        <p:spPr>
+          <a:xfrm>
+            <a:off x="8211312" y="1536192"/>
+            <a:ext cx="3054096" cy="1783080"/>
+          </a:xfrm>
+          <a:prstGeom prst="rect">
+            <a:avLst/>
+          </a:prstGeom>
+          <a:noFill/>
+        </p:spPr>
+        <p:txBody>
+          <a:bodyPr wrap="square" lIns="0" rIns="0" tIns="0" bIns="0">
+            <a:spAutoFit/>
+          </a:bodyPr>
+          <a:lstStyle/>
+          <a:p>
+            <a:pPr>
+              <a:defRPr sz="950" b="1">
+                <a:solidFill>
+                  <a:srgbClr val="D97706"/>
+                </a:solidFill>
+              </a:defRPr>
+            </a:pPr>
+            <a:r>
+              <a:t>3. MAXIMUM PORTFOLIO RISK</a:t>
+            </a:r>
+          </a:p>
+          <a:p>
+            <a:pPr>
+              <a:defRPr sz="1200" b="1">
+                <a:solidFill>
+                  <a:srgbClr val="0F172A"/>
+                </a:solidFill>
+              </a:defRPr>
+            </a:pPr>
+            <a:r>
+              <a:t>Baseline: 5.27% Drawdown</a:t>
+            </a:r>
+            <a:br/>
+            <a:r>
+              <a:t>With CAR: 4.92% Drawdown</a:t>
+            </a:r>
+          </a:p>
+          <a:p>
+            <a:pPr>
+              <a:defRPr sz="1100" b="1">
+                <a:solidFill>
+                  <a:srgbClr val="D97706"/>
+                </a:solidFill>
+              </a:defRPr>
+            </a:pPr>
+            <a:r>
+              <a:t>ONLY 0.35% RISK DIFFERENCE</a:t>
+            </a:r>
+          </a:p>
+          <a:p>
+            <a:pPr>
+              <a:defRPr sz="850">
+                <a:solidFill>
+                  <a:srgbClr val="64748B"/>
+                </a:solidFill>
+              </a:defRPr>
+            </a:pPr>
+            <a:r>
+              <a:t>CAR sacrificed ₹21.28L of profit for almost zero risk improvement.</a:t>
+            </a:r>
+          </a:p>
+        </p:txBody>
+      </p:sp>
+      <p:pic>
+        <p:nvPicPr>
+          <p:cNvPr id="11" name="Picture 10" descr="deck_profit_breakdown.png"/>
+          <p:cNvPicPr>
+            <a:picLocks noChangeAspect="1"/>
+          </p:cNvPicPr>
+          <p:nvPr/>
+        </p:nvPicPr>
+        <p:blipFill>
+          <a:blip r:embed="rId2"/>
+          <a:stretch>
+            <a:fillRect/>
+          </a:stretch>
+        </p:blipFill>
+        <p:spPr>
+          <a:xfrm>
+            <a:off x="731520" y="3611880"/>
+            <a:ext cx="5120640" cy="2834640"/>
+          </a:xfrm>
+          <a:prstGeom prst="rect">
+            <a:avLst/>
+          </a:prstGeom>
+        </p:spPr>
+      </p:pic>
+      <p:sp>
+        <p:nvSpPr>
+          <p:cNvPr id="12" name="Rounded Rectangle 11"/>
+          <p:cNvSpPr/>
+          <p:nvPr/>
+        </p:nvSpPr>
+        <p:spPr>
+          <a:xfrm>
+            <a:off x="6035040" y="3611880"/>
+            <a:ext cx="5394960" cy="2834640"/>
+          </a:xfrm>
+          <a:prstGeom prst="roundRect">
+            <a:avLst/>
+          </a:prstGeom>
+          <a:solidFill>
+            <a:srgbClr val="FFFFFF"/>
+          </a:solidFill>
+          <a:ln w="12700">
+            <a:solidFill>
+              <a:srgbClr val="E2E8F0"/>
+            </a:solidFill>
+          </a:ln>
+        </p:spPr>
+        <p:style>
+          <a:lnRef idx="1">
+            <a:schemeClr val="accent1"/>
+          </a:lnRef>
+          <a:fillRef idx="3">
+            <a:schemeClr val="accent1"/>
+          </a:fillRef>
+          <a:effectRef idx="2">
+            <a:schemeClr val="accent1"/>
+          </a:effectRef>
+          <a:fontRef idx="minor">
+            <a:schemeClr val="lt1"/>
+          </a:fontRef>
+        </p:style>
+        <p:txBody>
+          <a:bodyPr rtlCol="0" anchor="ctr"/>
+          <a:lstStyle/>
+          <a:p>
+            <a:pPr algn="ctr"/>
+          </a:p>
+        </p:txBody>
+      </p:sp>
+      <p:sp>
+        <p:nvSpPr>
+          <p:cNvPr id="13" name="TextBox 12"/>
+          <p:cNvSpPr txBox="1"/>
+          <p:nvPr/>
+        </p:nvSpPr>
+        <p:spPr>
+          <a:xfrm>
+            <a:off x="6217920" y="3749039"/>
+            <a:ext cx="5029200" cy="2560320"/>
+          </a:xfrm>
+          <a:prstGeom prst="rect">
+            <a:avLst/>
+          </a:prstGeom>
+          <a:noFill/>
+        </p:spPr>
+        <p:txBody>
+          <a:bodyPr wrap="square" lIns="0" rIns="0" tIns="0" bIns="0">
+            <a:spAutoFit/>
+          </a:bodyPr>
+          <a:lstStyle/>
+          <a:p>
+            <a:pPr>
+              <a:defRPr sz="1200" b="1">
+                <a:solidFill>
+                  <a:srgbClr val="2563EB"/>
+                </a:solidFill>
+              </a:defRPr>
+            </a:pPr>
+            <a:r>
+              <a:t>THE CORE TAKEAWAYS AT A GLANCE</a:t>
+            </a:r>
+          </a:p>
+          <a:p>
+            <a:pPr>
+              <a:spcAft>
+                <a:spcPts val="400"/>
+              </a:spcAft>
+              <a:defRPr sz="950">
+                <a:solidFill>
+                  <a:srgbClr val="0F172A"/>
+                </a:solidFill>
+              </a:defRPr>
+            </a:pPr>
+            <a:r>
+              <a:t>• Massive Cash Generation: Baseline realized Rs. 33.20L from 5% trades + Rs. 9.52L idle interest + Rs. 2.80L dividends = Rs. 45.53L total realized cash.</a:t>
+            </a:r>
+          </a:p>
+          <a:p>
+            <a:pPr>
+              <a:spcAft>
+                <a:spcPts val="400"/>
+              </a:spcAft>
+              <a:defRPr sz="950">
+                <a:solidFill>
+                  <a:srgbClr val="0F172A"/>
+                </a:solidFill>
+              </a:defRPr>
+            </a:pPr>
+            <a:r>
+              <a:t>• The Floating Drawdown is Irrelevant: The -Rs. 2.85L open dip is barely 6.2% of your Rs. 45.53L banked cash cushion. Net wealth is still Rs. 42.67L vs Rs. 21.40L.</a:t>
+            </a:r>
+          </a:p>
+          <a:p>
+            <a:pPr>
+              <a:spcAft>
+                <a:spcPts val="400"/>
+              </a:spcAft>
+              <a:defRPr sz="950">
+                <a:solidFill>
+                  <a:srgbClr val="0F172A"/>
+                </a:solidFill>
+              </a:defRPr>
+            </a:pPr>
+            <a:r>
+              <a:t>• Identical Capital Efficiency: Both models achieve ~28% Deployed XIRR when money is invested, but Baseline keeps capital active rather than sitting idle.</a:t>
+            </a:r>
+          </a:p>
+          <a:p>
+            <a:pPr>
+              <a:spcAft>
+                <a:spcPts val="400"/>
+              </a:spcAft>
+              <a:defRPr sz="950">
+                <a:solidFill>
+                  <a:srgbClr val="0F172A"/>
+                </a:solidFill>
+              </a:defRPr>
+            </a:pPr>
+            <a:r>
+              <a:t>• Ending Wealth Disparity: Initial Rs. 50.0L capital grew into Rs. 95.53 Lakhs in Baseline vs only Rs. 70.72 Lakhs with CAR.</a:t>
+            </a:r>
+          </a:p>
+        </p:txBody>
+      </p:sp>
+    </p:spTree>
+  </p:cSld>
+  <p:clrMapOvr>
+    <a:masterClrMapping/>
+  </p:clrMapOvr>
+</p:sld>
+</file>
+
+<file path=ppt/slides/slide13.xml><?xml version="1.0" encoding="utf-8"?>
+<p:sld xmlns:a="http://schemas.openxmlformats.org/drawingml/2006/main" xmlns:p="http://schemas.openxmlformats.org/presentationml/2006/main" xmlns:r="http://schemas.openxmlformats.org/officeDocument/2006/relationships">
+  <p:cSld>
+    <p:spTree>
+      <p:nvGrpSpPr>
+        <p:cNvPr id="1" name=""/>
+        <p:cNvGrpSpPr/>
+        <p:nvPr/>
+      </p:nvGrpSpPr>
+      <p:grpSpPr/>
+      <p:sp>
+        <p:nvSpPr>
+          <p:cNvPr id="2" name="Rectangle 1"/>
+          <p:cNvSpPr/>
+          <p:nvPr/>
+        </p:nvSpPr>
+        <p:spPr>
+          <a:xfrm>
+            <a:off x="0" y="0"/>
+            <a:ext cx="12191695" cy="6858000"/>
+          </a:xfrm>
+          <a:prstGeom prst="rect">
+            <a:avLst/>
+          </a:prstGeom>
+          <a:solidFill>
+            <a:srgbClr val="F8FAFC"/>
+          </a:solidFill>
+          <a:ln>
+            <a:solidFill>
+              <a:srgbClr val="F8FAFC"/>
+            </a:solidFill>
+          </a:ln>
+        </p:spPr>
+        <p:style>
+          <a:lnRef idx="1">
+            <a:schemeClr val="accent1"/>
+          </a:lnRef>
+          <a:fillRef idx="3">
+            <a:schemeClr val="accent1"/>
+          </a:fillRef>
+          <a:effectRef idx="2">
+            <a:schemeClr val="accent1"/>
+          </a:effectRef>
+          <a:fontRef idx="minor">
+            <a:schemeClr val="lt1"/>
+          </a:fontRef>
+        </p:style>
+        <p:txBody>
+          <a:bodyPr rtlCol="0" anchor="ctr"/>
+          <a:lstStyle/>
+          <a:p>
+            <a:pPr algn="ctr"/>
+          </a:p>
+        </p:txBody>
+      </p:sp>
+      <p:sp>
+        <p:nvSpPr>
+          <p:cNvPr id="3" name="TextBox 2"/>
+          <p:cNvSpPr txBox="1"/>
+          <p:nvPr/>
+        </p:nvSpPr>
+        <p:spPr>
+          <a:xfrm>
+            <a:off x="731520" y="365760"/>
+            <a:ext cx="10698480" cy="822960"/>
+          </a:xfrm>
+          <a:prstGeom prst="rect">
+            <a:avLst/>
+          </a:prstGeom>
+          <a:noFill/>
+        </p:spPr>
+        <p:txBody>
+          <a:bodyPr wrap="square" lIns="0" tIns="0" rIns="0" bIns="0">
+            <a:spAutoFit/>
+          </a:bodyPr>
+          <a:lstStyle/>
+          <a:p>
+            <a:pPr>
+              <a:defRPr sz="1000" b="1">
+                <a:solidFill>
+                  <a:srgbClr val="2563EB"/>
+                </a:solidFill>
+              </a:defRPr>
+            </a:pPr>
+            <a:r>
+              <a:t>STRATEGIC ANALYSIS &amp; CONCLUSION</a:t>
+            </a:r>
+          </a:p>
+          <a:p>
+            <a:pPr>
+              <a:defRPr sz="2200" b="1">
+                <a:solidFill>
+                  <a:srgbClr val="0F172A"/>
+                </a:solidFill>
+              </a:defRPr>
+            </a:pPr>
+            <a:r>
+              <a:t>Why No CAR (Baseline) is the Undisputed Winner: 4 Decisive Factors</a:t>
+            </a:r>
+          </a:p>
+        </p:txBody>
+      </p:sp>
+      <p:sp>
+        <p:nvSpPr>
+          <p:cNvPr id="4" name="Rectangle 3"/>
+          <p:cNvSpPr/>
+          <p:nvPr/>
+        </p:nvSpPr>
+        <p:spPr>
+          <a:xfrm>
+            <a:off x="731520" y="1234440"/>
+            <a:ext cx="10728655" cy="18288"/>
+          </a:xfrm>
+          <a:prstGeom prst="rect">
+            <a:avLst/>
+          </a:prstGeom>
+          <a:solidFill>
+            <a:srgbClr val="E2E8F0"/>
+          </a:solidFill>
+          <a:ln>
+            <a:solidFill>
+              <a:srgbClr val="E2E8F0"/>
+            </a:solidFill>
+          </a:ln>
+        </p:spPr>
+        <p:style>
+          <a:lnRef idx="1">
+            <a:schemeClr val="accent1"/>
+          </a:lnRef>
+          <a:fillRef idx="3">
+            <a:schemeClr val="accent1"/>
+          </a:fillRef>
+          <a:effectRef idx="2">
+            <a:schemeClr val="accent1"/>
+          </a:effectRef>
+          <a:fontRef idx="minor">
+            <a:schemeClr val="lt1"/>
+          </a:fontRef>
+        </p:style>
+        <p:txBody>
+          <a:bodyPr rtlCol="0" anchor="ctr"/>
+          <a:lstStyle/>
+          <a:p>
+            <a:pPr algn="ctr"/>
+          </a:p>
+        </p:txBody>
+      </p:sp>
+      <p:sp>
+        <p:nvSpPr>
+          <p:cNvPr id="5" name="Rounded Rectangle 4"/>
+          <p:cNvSpPr/>
+          <p:nvPr/>
+        </p:nvSpPr>
+        <p:spPr>
+          <a:xfrm>
+            <a:off x="731520" y="1417320"/>
+            <a:ext cx="5212080" cy="2240280"/>
+          </a:xfrm>
+          <a:prstGeom prst="roundRect">
+            <a:avLst/>
+          </a:prstGeom>
+          <a:solidFill>
+            <a:srgbClr val="ECFDF5"/>
+          </a:solidFill>
+          <a:ln w="12700">
+            <a:solidFill>
+              <a:srgbClr val="059669"/>
+            </a:solidFill>
+          </a:ln>
+        </p:spPr>
+        <p:style>
+          <a:lnRef idx="1">
+            <a:schemeClr val="accent1"/>
+          </a:lnRef>
+          <a:fillRef idx="3">
+            <a:schemeClr val="accent1"/>
+          </a:fillRef>
+          <a:effectRef idx="2">
+            <a:schemeClr val="accent1"/>
+          </a:effectRef>
+          <a:fontRef idx="minor">
+            <a:schemeClr val="lt1"/>
+          </a:fontRef>
+        </p:style>
+        <p:txBody>
+          <a:bodyPr rtlCol="0" anchor="ctr"/>
+          <a:lstStyle/>
+          <a:p>
+            <a:pPr algn="ctr"/>
+          </a:p>
+        </p:txBody>
+      </p:sp>
+      <p:sp>
+        <p:nvSpPr>
+          <p:cNvPr id="6" name="TextBox 5"/>
+          <p:cNvSpPr txBox="1"/>
+          <p:nvPr/>
+        </p:nvSpPr>
+        <p:spPr>
+          <a:xfrm>
+            <a:off x="914400" y="1554480"/>
+            <a:ext cx="4846320" cy="1965960"/>
+          </a:xfrm>
+          <a:prstGeom prst="rect">
+            <a:avLst/>
+          </a:prstGeom>
+          <a:noFill/>
+        </p:spPr>
+        <p:txBody>
+          <a:bodyPr wrap="square" lIns="0" rIns="0" tIns="0" bIns="0">
+            <a:spAutoFit/>
+          </a:bodyPr>
+          <a:lstStyle/>
+          <a:p>
+            <a:pPr>
+              <a:defRPr sz="950" b="1">
+                <a:solidFill>
+                  <a:srgbClr val="059669"/>
+                </a:solidFill>
+              </a:defRPr>
+            </a:pPr>
+            <a:r>
+              <a:t>PILLAR 1: CASH IN HAND TRUMPS PAPER FLOATING DRAWDOWN</a:t>
+            </a:r>
+          </a:p>
+          <a:p>
+            <a:pPr>
+              <a:spcAft>
+                <a:spcPts val="400"/>
+              </a:spcAft>
+              <a:defRPr sz="1200" b="1">
+                <a:solidFill>
+                  <a:srgbClr val="0F172A"/>
+                </a:solidFill>
+              </a:defRPr>
+            </a:pPr>
+            <a:r>
+              <a:t>+₹24.81 Lakhs Extra Cash dwarfs the -₹2.85L Dip</a:t>
+            </a:r>
+          </a:p>
+          <a:p>
+            <a:pPr>
+              <a:lnSpc>
+                <a:spcPct val="125000"/>
+              </a:lnSpc>
+              <a:defRPr sz="919">
+                <a:solidFill>
+                  <a:srgbClr val="0F172A"/>
+                </a:solidFill>
+              </a:defRPr>
+            </a:pPr>
+            <a:r>
+              <a:t>• Baseline realized ₹45.53 Lakhs in hard cash into bank reserves vs ₹20.72 Lakhs for CAR.</a:t>
+            </a:r>
+            <a:br/>
+            <a:r>
+              <a:t>• The -₹2.85 Lakhs floating drawdown at backtest end represents less than 6% of the banked profit cushion.</a:t>
+            </a:r>
+            <a:br/>
+            <a:r>
+              <a:t>• Even after fully paying out the floating dip, Baseline is still ahead by +₹21.28 Lakhs in pure net profit.</a:t>
+            </a:r>
+          </a:p>
+        </p:txBody>
+      </p:sp>
+      <p:sp>
+        <p:nvSpPr>
+          <p:cNvPr id="7" name="Rounded Rectangle 6"/>
+          <p:cNvSpPr/>
+          <p:nvPr/>
+        </p:nvSpPr>
+        <p:spPr>
+          <a:xfrm>
+            <a:off x="6217920" y="1417320"/>
+            <a:ext cx="5212080" cy="2240280"/>
+          </a:xfrm>
+          <a:prstGeom prst="roundRect">
+            <a:avLst/>
+          </a:prstGeom>
+          <a:solidFill>
+            <a:srgbClr val="EFF6FF"/>
+          </a:solidFill>
+          <a:ln w="12700">
+            <a:solidFill>
+              <a:srgbClr val="2563EB"/>
+            </a:solidFill>
+          </a:ln>
+        </p:spPr>
+        <p:style>
+          <a:lnRef idx="1">
+            <a:schemeClr val="accent1"/>
+          </a:lnRef>
+          <a:fillRef idx="3">
+            <a:schemeClr val="accent1"/>
+          </a:fillRef>
+          <a:effectRef idx="2">
+            <a:schemeClr val="accent1"/>
+          </a:effectRef>
+          <a:fontRef idx="minor">
+            <a:schemeClr val="lt1"/>
+          </a:fontRef>
+        </p:style>
+        <p:txBody>
+          <a:bodyPr rtlCol="0" anchor="ctr"/>
+          <a:lstStyle/>
+          <a:p>
+            <a:pPr algn="ctr"/>
+          </a:p>
+        </p:txBody>
+      </p:sp>
+      <p:sp>
+        <p:nvSpPr>
+          <p:cNvPr id="8" name="TextBox 7"/>
+          <p:cNvSpPr txBox="1"/>
+          <p:nvPr/>
+        </p:nvSpPr>
+        <p:spPr>
+          <a:xfrm>
+            <a:off x="6400800" y="1554480"/>
+            <a:ext cx="4846320" cy="1965960"/>
+          </a:xfrm>
+          <a:prstGeom prst="rect">
+            <a:avLst/>
+          </a:prstGeom>
+          <a:noFill/>
+        </p:spPr>
+        <p:txBody>
+          <a:bodyPr wrap="square" lIns="0" rIns="0" tIns="0" bIns="0">
+            <a:spAutoFit/>
+          </a:bodyPr>
+          <a:lstStyle/>
+          <a:p>
+            <a:pPr>
+              <a:defRPr sz="950" b="1">
+                <a:solidFill>
+                  <a:srgbClr val="2563EB"/>
+                </a:solidFill>
+              </a:defRPr>
+            </a:pPr>
+            <a:r>
+              <a:t>PILLAR 2: OVER-FILTERING STARVED THE COMPOUNDING MACHINE</a:t>
+            </a:r>
+          </a:p>
+          <a:p>
+            <a:pPr>
+              <a:spcAft>
+                <a:spcPts val="400"/>
+              </a:spcAft>
+              <a:defRPr sz="1200" b="1">
+                <a:solidFill>
+                  <a:srgbClr val="0F172A"/>
+                </a:solidFill>
+              </a:defRPr>
+            </a:pPr>
+            <a:r>
+              <a:t>Requiring 10 Days of Rising CAR Killed 979 Dip Bounces</a:t>
+            </a:r>
+          </a:p>
+          <a:p>
+            <a:pPr>
+              <a:lnSpc>
+                <a:spcPct val="125000"/>
+              </a:lnSpc>
+              <a:defRPr sz="919">
+                <a:solidFill>
+                  <a:srgbClr val="0F172A"/>
+                </a:solidFill>
+              </a:defRPr>
+            </a:pPr>
+            <a:r>
+              <a:t>• The CAR filter requires 10 consecutive rising sessions anchored to the 52W High before entering.</a:t>
+            </a:r>
+            <a:br/>
+            <a:r>
+              <a:t>• During severe corrections, stocks bounce quickly for 5% targets before any 10-day rising trend confirms.</a:t>
+            </a:r>
+            <a:br/>
+            <a:r>
+              <a:t>• By missing 979 profitable dip-bounces, CAR starved the portfolio of reinvestable compounding cash.</a:t>
+            </a:r>
+          </a:p>
+        </p:txBody>
+      </p:sp>
+      <p:sp>
+        <p:nvSpPr>
+          <p:cNvPr id="9" name="Rounded Rectangle 8"/>
+          <p:cNvSpPr/>
+          <p:nvPr/>
+        </p:nvSpPr>
+        <p:spPr>
+          <a:xfrm>
+            <a:off x="731520" y="3794760"/>
+            <a:ext cx="5212080" cy="2240280"/>
+          </a:xfrm>
+          <a:prstGeom prst="roundRect">
+            <a:avLst/>
+          </a:prstGeom>
+          <a:solidFill>
+            <a:srgbClr val="FEF3C7"/>
+          </a:solidFill>
+          <a:ln w="12700">
+            <a:solidFill>
+              <a:srgbClr val="D97706"/>
+            </a:solidFill>
+          </a:ln>
+        </p:spPr>
+        <p:style>
+          <a:lnRef idx="1">
+            <a:schemeClr val="accent1"/>
+          </a:lnRef>
+          <a:fillRef idx="3">
+            <a:schemeClr val="accent1"/>
+          </a:fillRef>
+          <a:effectRef idx="2">
+            <a:schemeClr val="accent1"/>
+          </a:effectRef>
+          <a:fontRef idx="minor">
+            <a:schemeClr val="lt1"/>
+          </a:fontRef>
+        </p:style>
+        <p:txBody>
+          <a:bodyPr rtlCol="0" anchor="ctr"/>
+          <a:lstStyle/>
+          <a:p>
+            <a:pPr algn="ctr"/>
+          </a:p>
+        </p:txBody>
+      </p:sp>
+      <p:sp>
+        <p:nvSpPr>
+          <p:cNvPr id="10" name="TextBox 9"/>
+          <p:cNvSpPr txBox="1"/>
+          <p:nvPr/>
+        </p:nvSpPr>
+        <p:spPr>
+          <a:xfrm>
+            <a:off x="914400" y="3931920"/>
+            <a:ext cx="4846320" cy="1965960"/>
+          </a:xfrm>
+          <a:prstGeom prst="rect">
+            <a:avLst/>
+          </a:prstGeom>
+          <a:noFill/>
+        </p:spPr>
+        <p:txBody>
+          <a:bodyPr wrap="square" lIns="0" rIns="0" tIns="0" bIns="0">
+            <a:spAutoFit/>
+          </a:bodyPr>
+          <a:lstStyle/>
+          <a:p>
+            <a:pPr>
+              <a:defRPr sz="950" b="1">
+                <a:solidFill>
+                  <a:srgbClr val="D97706"/>
+                </a:solidFill>
+              </a:defRPr>
+            </a:pPr>
+            <a:r>
+              <a:t>PILLAR 3: THE 0.35% DRAWDOWN ILLUSION</a:t>
+            </a:r>
+          </a:p>
+          <a:p>
+            <a:pPr>
+              <a:spcAft>
+                <a:spcPts val="400"/>
+              </a:spcAft>
+              <a:defRPr sz="1200" b="1">
+                <a:solidFill>
+                  <a:srgbClr val="0F172A"/>
+                </a:solidFill>
+              </a:defRPr>
+            </a:pPr>
+            <a:r>
+              <a:t>Sacrificing ₹21.28L Profit for 0.35% Risk is Irrational</a:t>
+            </a:r>
+          </a:p>
+          <a:p>
+            <a:pPr>
+              <a:lnSpc>
+                <a:spcPct val="125000"/>
+              </a:lnSpc>
+              <a:defRPr sz="919">
+                <a:solidFill>
+                  <a:srgbClr val="0F172A"/>
+                </a:solidFill>
+              </a:defRPr>
+            </a:pPr>
+            <a:r>
+              <a:t>• Portfolio Max Drawdown was 4.92% with CAR vs 5.27% without CAR — a mere 0.35% difference!</a:t>
+            </a:r>
+            <a:br/>
+            <a:r>
+              <a:t>• Giving up literally HALF of your total returns (+42.8% vs +85.4%) to gain a 0.35% drawdown cushion is an indefensible risk-reward trade-off.</a:t>
+            </a:r>
+            <a:br/>
+            <a:r>
+              <a:t>• The portfolio-level diversification across 50 stocks already handles risk management natively.</a:t>
+            </a:r>
+          </a:p>
+        </p:txBody>
+      </p:sp>
+      <p:sp>
+        <p:nvSpPr>
+          <p:cNvPr id="11" name="Rounded Rectangle 10"/>
+          <p:cNvSpPr/>
+          <p:nvPr/>
+        </p:nvSpPr>
+        <p:spPr>
+          <a:xfrm>
+            <a:off x="6217920" y="3794760"/>
+            <a:ext cx="5212080" cy="2240280"/>
+          </a:xfrm>
+          <a:prstGeom prst="roundRect">
+            <a:avLst/>
+          </a:prstGeom>
+          <a:solidFill>
+            <a:srgbClr val="F5F3FF"/>
+          </a:solidFill>
+          <a:ln w="12700">
+            <a:solidFill>
+              <a:srgbClr val="7C3AED"/>
+            </a:solidFill>
+          </a:ln>
+        </p:spPr>
+        <p:style>
+          <a:lnRef idx="1">
+            <a:schemeClr val="accent1"/>
+          </a:lnRef>
+          <a:fillRef idx="3">
+            <a:schemeClr val="accent1"/>
+          </a:fillRef>
+          <a:effectRef idx="2">
+            <a:schemeClr val="accent1"/>
+          </a:effectRef>
+          <a:fontRef idx="minor">
+            <a:schemeClr val="lt1"/>
+          </a:fontRef>
+        </p:style>
+        <p:txBody>
+          <a:bodyPr rtlCol="0" anchor="ctr"/>
+          <a:lstStyle/>
+          <a:p>
+            <a:pPr algn="ctr"/>
+          </a:p>
+        </p:txBody>
+      </p:sp>
+      <p:sp>
+        <p:nvSpPr>
+          <p:cNvPr id="12" name="TextBox 11"/>
+          <p:cNvSpPr txBox="1"/>
+          <p:nvPr/>
+        </p:nvSpPr>
+        <p:spPr>
+          <a:xfrm>
+            <a:off x="6400800" y="3931920"/>
+            <a:ext cx="4846320" cy="1965960"/>
+          </a:xfrm>
+          <a:prstGeom prst="rect">
+            <a:avLst/>
+          </a:prstGeom>
+          <a:noFill/>
+        </p:spPr>
+        <p:txBody>
+          <a:bodyPr wrap="square" lIns="0" rIns="0" tIns="0" bIns="0">
+            <a:spAutoFit/>
+          </a:bodyPr>
+          <a:lstStyle/>
+          <a:p>
+            <a:pPr>
+              <a:defRPr sz="950" b="1">
+                <a:solidFill>
+                  <a:srgbClr val="7C3AED"/>
+                </a:solidFill>
+              </a:defRPr>
+            </a:pPr>
+            <a:r>
+              <a:t>PILLAR 4: MISMATCH WITH DARVAS SWING PHILOSOPHY</a:t>
+            </a:r>
+          </a:p>
+          <a:p>
+            <a:pPr>
+              <a:spcAft>
+                <a:spcPts val="400"/>
+              </a:spcAft>
+              <a:defRPr sz="1200" b="1">
+                <a:solidFill>
+                  <a:srgbClr val="0F172A"/>
+                </a:solidFill>
+              </a:defRPr>
+            </a:pPr>
+            <a:r>
+              <a:t>Dip Harvesting is Mean-Reverting, Not Trend Following</a:t>
+            </a:r>
+          </a:p>
+          <a:p>
+            <a:pPr>
+              <a:lnSpc>
+                <a:spcPct val="125000"/>
+              </a:lnSpc>
+              <a:defRPr sz="919">
+                <a:solidFill>
+                  <a:srgbClr val="0F172A"/>
+                </a:solidFill>
+              </a:defRPr>
+            </a:pPr>
+            <a:r>
+              <a:t>• Bullish macro compounders ride long-term trends; Bearish dip tranches harvest short-term panic bounces.</a:t>
+            </a:r>
+            <a:br/>
+            <a:r>
+              <a:t>• Forcing a long-term trend filter (CAR rising 10d) onto mean-reverting dip trades is theoretically contradictory.</a:t>
+            </a:r>
+            <a:br/>
+            <a:r>
+              <a:t>• The baseline rule (Friday Close &gt; Previous Week High) is the ideal agile trigger for dip harvesting.</a:t>
+            </a:r>
+          </a:p>
+        </p:txBody>
+      </p:sp>
+      <p:sp>
+        <p:nvSpPr>
+          <p:cNvPr id="13" name="Rounded Rectangle 12"/>
+          <p:cNvSpPr/>
+          <p:nvPr/>
+        </p:nvSpPr>
+        <p:spPr>
+          <a:xfrm>
+            <a:off x="731520" y="6172200"/>
+            <a:ext cx="10698480" cy="502920"/>
+          </a:xfrm>
+          <a:prstGeom prst="roundRect">
+            <a:avLst/>
+          </a:prstGeom>
+          <a:solidFill>
+            <a:srgbClr val="0F172A"/>
+          </a:solidFill>
+          <a:ln w="12700">
+            <a:solidFill>
+              <a:srgbClr val="0F172A"/>
+            </a:solidFill>
+          </a:ln>
+        </p:spPr>
+        <p:style>
+          <a:lnRef idx="1">
+            <a:schemeClr val="accent1"/>
+          </a:lnRef>
+          <a:fillRef idx="3">
+            <a:schemeClr val="accent1"/>
+          </a:fillRef>
+          <a:effectRef idx="2">
+            <a:schemeClr val="accent1"/>
+          </a:effectRef>
+          <a:fontRef idx="minor">
+            <a:schemeClr val="lt1"/>
+          </a:fontRef>
+        </p:style>
+        <p:txBody>
+          <a:bodyPr rtlCol="0" anchor="ctr"/>
+          <a:lstStyle/>
+          <a:p>
+            <a:pPr algn="ctr"/>
+          </a:p>
+        </p:txBody>
+      </p:sp>
+      <p:sp>
+        <p:nvSpPr>
+          <p:cNvPr id="14" name="TextBox 13"/>
+          <p:cNvSpPr txBox="1"/>
+          <p:nvPr/>
+        </p:nvSpPr>
+        <p:spPr>
+          <a:xfrm>
+            <a:off x="822960" y="6217920"/>
+            <a:ext cx="10515600" cy="411480"/>
+          </a:xfrm>
+          <a:prstGeom prst="rect">
+            <a:avLst/>
+          </a:prstGeom>
+          <a:noFill/>
+        </p:spPr>
+        <p:txBody>
+          <a:bodyPr wrap="square" lIns="0" rIns="0" tIns="0" bIns="0">
+            <a:spAutoFit/>
+          </a:bodyPr>
+          <a:lstStyle/>
+          <a:p>
+            <a:pPr algn="ctr">
+              <a:defRPr sz="1000" b="1">
+                <a:solidFill>
+                  <a:srgbClr val="FEF08A"/>
+                </a:solidFill>
+              </a:defRPr>
+            </a:pPr>
+            <a:r>
+              <a:t>FINAL RECOMMENDATION: Stick to Baseline (No CAR) — Generates Rs. 42.67 Lakhs Net Profit (+85.4%), Banks Rs. 45.53L Cash, and Delivers Industry-Leading 28.05% Deployed XIRR.</a:t>
             </a:r>
           </a:p>
         </p:txBody>

</xml_diff>

<commit_message>
refactor: clean up presentation files, ignore office temp files, and fix spreadsheet formula syntax in scanner script
</commit_message>
<xml_diff>
--- a/Darvas_Strategy_Rulebook_Deck_v2.pptx
+++ b/Darvas_Strategy_Rulebook_Deck_v2.pptx
@@ -15,9 +15,9 @@
     <p:sldId id="263" r:id="rId9"/>
     <p:sldId id="264" r:id="rId10"/>
     <p:sldId id="265" r:id="rId11"/>
-    <p:sldId id="266" r:id="rId16"/>
-    <p:sldId id="267" r:id="rId17"/>
-    <p:sldId id="268" r:id="rId18"/>
+    <p:sldId id="266" r:id="rId12"/>
+    <p:sldId id="267" r:id="rId13"/>
+    <p:sldId id="268" r:id="rId14"/>
   </p:sldIdLst>
   <p:sldSz cx="12192000" cy="6858000"/>
   <p:notesSz cx="6858000" cy="9144000"/>
@@ -314,7 +314,7 @@
           <a:p>
             <a:fld id="{5BCAD085-E8A6-8845-BD4E-CB4CCA059FC4}" type="datetimeFigureOut">
               <a:rPr lang="en-US" smtClean="0"/>
-              <a:t>10/17/2026</a:t>
+              <a:t>10/25/2026</a:t>
             </a:fld>
             <a:endParaRPr lang="en-US"/>
           </a:p>
@@ -482,7 +482,7 @@
           <a:p>
             <a:fld id="{5BCAD085-E8A6-8845-BD4E-CB4CCA059FC4}" type="datetimeFigureOut">
               <a:rPr lang="en-US" smtClean="0"/>
-              <a:t>10/17/2026</a:t>
+              <a:t>10/25/2026</a:t>
             </a:fld>
             <a:endParaRPr lang="en-US"/>
           </a:p>
@@ -660,7 +660,7 @@
           <a:p>
             <a:fld id="{5BCAD085-E8A6-8845-BD4E-CB4CCA059FC4}" type="datetimeFigureOut">
               <a:rPr lang="en-US" smtClean="0"/>
-              <a:t>10/17/2026</a:t>
+              <a:t>10/25/2026</a:t>
             </a:fld>
             <a:endParaRPr lang="en-US"/>
           </a:p>
@@ -828,7 +828,7 @@
           <a:p>
             <a:fld id="{5BCAD085-E8A6-8845-BD4E-CB4CCA059FC4}" type="datetimeFigureOut">
               <a:rPr lang="en-US" smtClean="0"/>
-              <a:t>10/17/2026</a:t>
+              <a:t>10/25/2026</a:t>
             </a:fld>
             <a:endParaRPr lang="en-US"/>
           </a:p>
@@ -1073,7 +1073,7 @@
           <a:p>
             <a:fld id="{5BCAD085-E8A6-8845-BD4E-CB4CCA059FC4}" type="datetimeFigureOut">
               <a:rPr lang="en-US" smtClean="0"/>
-              <a:t>10/17/2026</a:t>
+              <a:t>10/25/2026</a:t>
             </a:fld>
             <a:endParaRPr lang="en-US"/>
           </a:p>
@@ -1358,7 +1358,7 @@
           <a:p>
             <a:fld id="{5BCAD085-E8A6-8845-BD4E-CB4CCA059FC4}" type="datetimeFigureOut">
               <a:rPr lang="en-US" smtClean="0"/>
-              <a:t>10/17/2026</a:t>
+              <a:t>10/25/2026</a:t>
             </a:fld>
             <a:endParaRPr lang="en-US"/>
           </a:p>
@@ -1777,7 +1777,7 @@
           <a:p>
             <a:fld id="{5BCAD085-E8A6-8845-BD4E-CB4CCA059FC4}" type="datetimeFigureOut">
               <a:rPr lang="en-US" smtClean="0"/>
-              <a:t>10/17/2026</a:t>
+              <a:t>10/25/2026</a:t>
             </a:fld>
             <a:endParaRPr lang="en-US"/>
           </a:p>
@@ -1894,7 +1894,7 @@
           <a:p>
             <a:fld id="{5BCAD085-E8A6-8845-BD4E-CB4CCA059FC4}" type="datetimeFigureOut">
               <a:rPr lang="en-US" smtClean="0"/>
-              <a:t>10/17/2026</a:t>
+              <a:t>10/25/2026</a:t>
             </a:fld>
             <a:endParaRPr lang="en-US"/>
           </a:p>
@@ -1989,7 +1989,7 @@
           <a:p>
             <a:fld id="{5BCAD085-E8A6-8845-BD4E-CB4CCA059FC4}" type="datetimeFigureOut">
               <a:rPr lang="en-US" smtClean="0"/>
-              <a:t>10/17/2026</a:t>
+              <a:t>10/25/2026</a:t>
             </a:fld>
             <a:endParaRPr lang="en-US"/>
           </a:p>
@@ -2264,7 +2264,7 @@
           <a:p>
             <a:fld id="{5BCAD085-E8A6-8845-BD4E-CB4CCA059FC4}" type="datetimeFigureOut">
               <a:rPr lang="en-US" smtClean="0"/>
-              <a:t>10/17/2026</a:t>
+              <a:t>10/25/2026</a:t>
             </a:fld>
             <a:endParaRPr lang="en-US"/>
           </a:p>
@@ -2516,7 +2516,7 @@
           <a:p>
             <a:fld id="{5BCAD085-E8A6-8845-BD4E-CB4CCA059FC4}" type="datetimeFigureOut">
               <a:rPr lang="en-US" smtClean="0"/>
-              <a:t>10/17/2026</a:t>
+              <a:t>10/25/2026</a:t>
             </a:fld>
             <a:endParaRPr lang="en-US"/>
           </a:p>
@@ -2727,7 +2727,7 @@
           <a:p>
             <a:fld id="{5BCAD085-E8A6-8845-BD4E-CB4CCA059FC4}" type="datetimeFigureOut">
               <a:rPr lang="en-US" smtClean="0"/>
-              <a:t>10/17/2026</a:t>
+              <a:t>10/25/2026</a:t>
             </a:fld>
             <a:endParaRPr lang="en-US"/>
           </a:p>
@@ -3150,60 +3150,6 @@
       </p:sp>
       <p:sp>
         <p:nvSpPr>
-          <p:cNvPr id="3" name="Rounded Rectangle 2"/>
-          <p:cNvSpPr/>
-          <p:nvPr/>
-        </p:nvSpPr>
-        <p:spPr>
-          <a:xfrm>
-            <a:off x="914400" y="1097280"/>
-            <a:ext cx="4754880" cy="411480"/>
-          </a:xfrm>
-          <a:prstGeom prst="roundRect">
-            <a:avLst/>
-          </a:prstGeom>
-          <a:solidFill>
-            <a:srgbClr val="1E293B"/>
-          </a:solidFill>
-          <a:ln>
-            <a:solidFill>
-              <a:srgbClr val="334155"/>
-            </a:solidFill>
-          </a:ln>
-        </p:spPr>
-        <p:style>
-          <a:lnRef idx="1">
-            <a:schemeClr val="accent1"/>
-          </a:lnRef>
-          <a:fillRef idx="3">
-            <a:schemeClr val="accent1"/>
-          </a:fillRef>
-          <a:effectRef idx="2">
-            <a:schemeClr val="accent1"/>
-          </a:effectRef>
-          <a:fontRef idx="minor">
-            <a:schemeClr val="lt1"/>
-          </a:fontRef>
-        </p:style>
-        <p:txBody>
-          <a:bodyPr rtlCol="0" anchor="ctr"/>
-          <a:lstStyle/>
-          <a:p>
-            <a:pPr algn="ctr">
-              <a:defRPr sz="1100" b="1">
-                <a:solidFill>
-                  <a:srgbClr val="38BDF8"/>
-                </a:solidFill>
-              </a:defRPr>
-            </a:pPr>
-            <a:r>
-              <a:t>★ SYSTEMATIC TRADING &amp; BACKTESTING ENGINE</a:t>
-            </a:r>
-          </a:p>
-        </p:txBody>
-      </p:sp>
-      <p:sp>
-        <p:nvSpPr>
           <p:cNvPr id="4" name="TextBox 3"/>
           <p:cNvSpPr txBox="1"/>
           <p:nvPr/>
@@ -3211,7 +3157,7 @@
         <p:spPr>
           <a:xfrm>
             <a:off x="914400" y="1737360"/>
-            <a:ext cx="10332720" cy="2560320"/>
+            <a:ext cx="10332720" cy="1328569"/>
           </a:xfrm>
           <a:prstGeom prst="rect">
             <a:avLst/>
@@ -3232,8 +3178,18 @@
               </a:defRPr>
             </a:pPr>
             <a:r>
-              <a:t>The Darvas Bearish + Bullish Combo</a:t>
-            </a:r>
+              <a:rPr lang="en-IN" dirty="0"/>
+              <a:t>Multi Engine </a:t>
+            </a:r>
+            <a:r>
+              <a:rPr dirty="0"/>
+              <a:t>Darvas </a:t>
+            </a:r>
+            <a:r>
+              <a:rPr lang="en-IN" dirty="0"/>
+              <a:t>Strategy</a:t>
+            </a:r>
+            <a:endParaRPr dirty="0"/>
           </a:p>
           <a:p>
             <a:pPr>
@@ -3247,10 +3203,22 @@
               </a:defRPr>
             </a:pPr>
             <a:r>
-              <a:t>Operational Rulebook &amp; Behind-the-Scenes Backtesting Mechanics</a:t>
-            </a:r>
-            <a:br/>
-            <a:r>
+              <a:rPr dirty="0"/>
+              <a:t>Operational Rulebook &amp; Behind-the-Scenes </a:t>
+            </a:r>
+            <a:r>
+              <a:rPr dirty="0" err="1"/>
+              <a:t>Backtesting</a:t>
+            </a:r>
+            <a:r>
+              <a:rPr dirty="0"/>
+              <a:t> Mechanics</a:t>
+            </a:r>
+            <a:br>
+              <a:rPr dirty="0"/>
+            </a:br>
+            <a:r>
+              <a:rPr dirty="0"/>
               <a:t>4-Tranche Capital Architecture (Rs. 40,000 Portfolio) | Live Case Study: INFY (Infosys Ltd)</a:t>
             </a:r>
           </a:p>
@@ -3900,7 +3868,7 @@
 </file>
 
 <file path=ppt/slides/slide11.xml><?xml version="1.0" encoding="utf-8"?>
-<p:sld xmlns:a="http://schemas.openxmlformats.org/drawingml/2006/main" xmlns:p="http://schemas.openxmlformats.org/presentationml/2006/main" xmlns:r="http://schemas.openxmlformats.org/officeDocument/2006/relationships">
+<p:sld xmlns:a="http://schemas.openxmlformats.org/drawingml/2006/main" xmlns:r="http://schemas.openxmlformats.org/officeDocument/2006/relationships" xmlns:p="http://schemas.openxmlformats.org/presentationml/2006/main">
   <p:cSld>
     <p:spTree>
       <p:nvGrpSpPr>
@@ -3908,7 +3876,14 @@
         <p:cNvGrpSpPr/>
         <p:nvPr/>
       </p:nvGrpSpPr>
-      <p:grpSpPr/>
+      <p:grpSpPr>
+        <a:xfrm>
+          <a:off x="0" y="0"/>
+          <a:ext cx="0" cy="0"/>
+          <a:chOff x="0" y="0"/>
+          <a:chExt cx="0" cy="0"/>
+        </a:xfrm>
+      </p:grpSpPr>
       <p:sp>
         <p:nvSpPr>
           <p:cNvPr id="2" name="Rectangle 1"/>
@@ -3951,6 +3926,7 @@
           <a:lstStyle/>
           <a:p>
             <a:pPr algn="ctr"/>
+            <a:endParaRPr/>
           </a:p>
         </p:txBody>
       </p:sp>
@@ -4043,6 +4019,7 @@
           <a:lstStyle/>
           <a:p>
             <a:pPr algn="ctr"/>
+            <a:endParaRPr/>
           </a:p>
         </p:txBody>
       </p:sp>
@@ -4065,10 +4042,34 @@
                 <a:tableStyleId>{5C22544A-7EE6-4342-B048-85BDC9FD1C3A}</a:tableStyleId>
               </a:tblPr>
               <a:tblGrid>
-                <a:gridCol w="2286000"/>
-                <a:gridCol w="1371600"/>
-                <a:gridCol w="1463040"/>
-                <a:gridCol w="1371600"/>
+                <a:gridCol w="2286000">
+                  <a:extLst>
+                    <a:ext uri="{9D8B030D-6E8A-4147-A177-3AD203B41FA5}">
+                      <a16:colId xmlns:a16="http://schemas.microsoft.com/office/drawing/2014/main" val="20000"/>
+                    </a:ext>
+                  </a:extLst>
+                </a:gridCol>
+                <a:gridCol w="1371600">
+                  <a:extLst>
+                    <a:ext uri="{9D8B030D-6E8A-4147-A177-3AD203B41FA5}">
+                      <a16:colId xmlns:a16="http://schemas.microsoft.com/office/drawing/2014/main" val="20001"/>
+                    </a:ext>
+                  </a:extLst>
+                </a:gridCol>
+                <a:gridCol w="1463040">
+                  <a:extLst>
+                    <a:ext uri="{9D8B030D-6E8A-4147-A177-3AD203B41FA5}">
+                      <a16:colId xmlns:a16="http://schemas.microsoft.com/office/drawing/2014/main" val="20002"/>
+                    </a:ext>
+                  </a:extLst>
+                </a:gridCol>
+                <a:gridCol w="1371600">
+                  <a:extLst>
+                    <a:ext uri="{9D8B030D-6E8A-4147-A177-3AD203B41FA5}">
+                      <a16:colId xmlns:a16="http://schemas.microsoft.com/office/drawing/2014/main" val="20003"/>
+                    </a:ext>
+                  </a:extLst>
+                </a:gridCol>
               </a:tblGrid>
               <a:tr h="359228">
                 <a:tc>
@@ -4163,6 +4164,11 @@
                     </a:solidFill>
                   </a:tcPr>
                 </a:tc>
+                <a:extLst>
+                  <a:ext uri="{0D108BD9-81ED-4DB2-BD59-A6C34878D82A}">
+                    <a16:rowId xmlns:a16="http://schemas.microsoft.com/office/drawing/2014/main" val="10000"/>
+                  </a:ext>
+                </a:extLst>
               </a:tr>
               <a:tr h="359228">
                 <a:tc>
@@ -4257,6 +4263,11 @@
                     </a:solidFill>
                   </a:tcPr>
                 </a:tc>
+                <a:extLst>
+                  <a:ext uri="{0D108BD9-81ED-4DB2-BD59-A6C34878D82A}">
+                    <a16:rowId xmlns:a16="http://schemas.microsoft.com/office/drawing/2014/main" val="10001"/>
+                  </a:ext>
+                </a:extLst>
               </a:tr>
               <a:tr h="359228">
                 <a:tc>
@@ -4351,6 +4362,11 @@
                     </a:solidFill>
                   </a:tcPr>
                 </a:tc>
+                <a:extLst>
+                  <a:ext uri="{0D108BD9-81ED-4DB2-BD59-A6C34878D82A}">
+                    <a16:rowId xmlns:a16="http://schemas.microsoft.com/office/drawing/2014/main" val="10002"/>
+                  </a:ext>
+                </a:extLst>
               </a:tr>
               <a:tr h="359228">
                 <a:tc>
@@ -4445,6 +4461,11 @@
                     </a:solidFill>
                   </a:tcPr>
                 </a:tc>
+                <a:extLst>
+                  <a:ext uri="{0D108BD9-81ED-4DB2-BD59-A6C34878D82A}">
+                    <a16:rowId xmlns:a16="http://schemas.microsoft.com/office/drawing/2014/main" val="10003"/>
+                  </a:ext>
+                </a:extLst>
               </a:tr>
               <a:tr h="359228">
                 <a:tc>
@@ -4539,6 +4560,11 @@
                     </a:solidFill>
                   </a:tcPr>
                 </a:tc>
+                <a:extLst>
+                  <a:ext uri="{0D108BD9-81ED-4DB2-BD59-A6C34878D82A}">
+                    <a16:rowId xmlns:a16="http://schemas.microsoft.com/office/drawing/2014/main" val="10004"/>
+                  </a:ext>
+                </a:extLst>
               </a:tr>
               <a:tr h="359228">
                 <a:tc>
@@ -4633,6 +4659,11 @@
                     </a:solidFill>
                   </a:tcPr>
                 </a:tc>
+                <a:extLst>
+                  <a:ext uri="{0D108BD9-81ED-4DB2-BD59-A6C34878D82A}">
+                    <a16:rowId xmlns:a16="http://schemas.microsoft.com/office/drawing/2014/main" val="10005"/>
+                  </a:ext>
+                </a:extLst>
               </a:tr>
               <a:tr h="359228">
                 <a:tc>
@@ -4727,6 +4758,11 @@
                     </a:solidFill>
                   </a:tcPr>
                 </a:tc>
+                <a:extLst>
+                  <a:ext uri="{0D108BD9-81ED-4DB2-BD59-A6C34878D82A}">
+                    <a16:rowId xmlns:a16="http://schemas.microsoft.com/office/drawing/2014/main" val="10006"/>
+                  </a:ext>
+                </a:extLst>
               </a:tr>
               <a:tr h="359228">
                 <a:tc>
@@ -4821,6 +4857,11 @@
                     </a:solidFill>
                   </a:tcPr>
                 </a:tc>
+                <a:extLst>
+                  <a:ext uri="{0D108BD9-81ED-4DB2-BD59-A6C34878D82A}">
+                    <a16:rowId xmlns:a16="http://schemas.microsoft.com/office/drawing/2014/main" val="10007"/>
+                  </a:ext>
+                </a:extLst>
               </a:tr>
               <a:tr h="359228">
                 <a:tc>
@@ -4915,6 +4956,11 @@
                     </a:solidFill>
                   </a:tcPr>
                 </a:tc>
+                <a:extLst>
+                  <a:ext uri="{0D108BD9-81ED-4DB2-BD59-A6C34878D82A}">
+                    <a16:rowId xmlns:a16="http://schemas.microsoft.com/office/drawing/2014/main" val="10008"/>
+                  </a:ext>
+                </a:extLst>
               </a:tr>
               <a:tr h="359228">
                 <a:tc>
@@ -5009,6 +5055,11 @@
                     </a:solidFill>
                   </a:tcPr>
                 </a:tc>
+                <a:extLst>
+                  <a:ext uri="{0D108BD9-81ED-4DB2-BD59-A6C34878D82A}">
+                    <a16:rowId xmlns:a16="http://schemas.microsoft.com/office/drawing/2014/main" val="10009"/>
+                  </a:ext>
+                </a:extLst>
               </a:tr>
               <a:tr h="359228">
                 <a:tc>
@@ -5103,6 +5154,11 @@
                     </a:solidFill>
                   </a:tcPr>
                 </a:tc>
+                <a:extLst>
+                  <a:ext uri="{0D108BD9-81ED-4DB2-BD59-A6C34878D82A}">
+                    <a16:rowId xmlns:a16="http://schemas.microsoft.com/office/drawing/2014/main" val="10010"/>
+                  </a:ext>
+                </a:extLst>
               </a:tr>
               <a:tr h="359228">
                 <a:tc>
@@ -5197,6 +5253,11 @@
                     </a:solidFill>
                   </a:tcPr>
                 </a:tc>
+                <a:extLst>
+                  <a:ext uri="{0D108BD9-81ED-4DB2-BD59-A6C34878D82A}">
+                    <a16:rowId xmlns:a16="http://schemas.microsoft.com/office/drawing/2014/main" val="10011"/>
+                  </a:ext>
+                </a:extLst>
               </a:tr>
               <a:tr h="359228">
                 <a:tc>
@@ -5291,6 +5352,11 @@
                     </a:solidFill>
                   </a:tcPr>
                 </a:tc>
+                <a:extLst>
+                  <a:ext uri="{0D108BD9-81ED-4DB2-BD59-A6C34878D82A}">
+                    <a16:rowId xmlns:a16="http://schemas.microsoft.com/office/drawing/2014/main" val="10012"/>
+                  </a:ext>
+                </a:extLst>
               </a:tr>
               <a:tr h="359236">
                 <a:tc>
@@ -5385,6 +5451,11 @@
                     </a:solidFill>
                   </a:tcPr>
                 </a:tc>
+                <a:extLst>
+                  <a:ext uri="{0D108BD9-81ED-4DB2-BD59-A6C34878D82A}">
+                    <a16:rowId xmlns:a16="http://schemas.microsoft.com/office/drawing/2014/main" val="10013"/>
+                  </a:ext>
+                </a:extLst>
               </a:tr>
             </a:tbl>
           </a:graphicData>
@@ -5456,6 +5527,7 @@
           <a:lstStyle/>
           <a:p>
             <a:pPr algn="ctr"/>
+            <a:endParaRPr/>
           </a:p>
         </p:txBody>
       </p:sp>
@@ -5476,7 +5548,7 @@
           <a:noFill/>
         </p:spPr>
         <p:txBody>
-          <a:bodyPr wrap="square" lIns="0" rIns="0" tIns="0" bIns="0">
+          <a:bodyPr wrap="square" lIns="0" tIns="0" rIns="0" bIns="0">
             <a:spAutoFit/>
           </a:bodyPr>
           <a:lstStyle/>
@@ -5523,7 +5595,7 @@
 </file>
 
 <file path=ppt/slides/slide12.xml><?xml version="1.0" encoding="utf-8"?>
-<p:sld xmlns:a="http://schemas.openxmlformats.org/drawingml/2006/main" xmlns:p="http://schemas.openxmlformats.org/presentationml/2006/main" xmlns:r="http://schemas.openxmlformats.org/officeDocument/2006/relationships">
+<p:sld xmlns:a="http://schemas.openxmlformats.org/drawingml/2006/main" xmlns:r="http://schemas.openxmlformats.org/officeDocument/2006/relationships" xmlns:p="http://schemas.openxmlformats.org/presentationml/2006/main">
   <p:cSld>
     <p:spTree>
       <p:nvGrpSpPr>
@@ -5531,7 +5603,14 @@
         <p:cNvGrpSpPr/>
         <p:nvPr/>
       </p:nvGrpSpPr>
-      <p:grpSpPr/>
+      <p:grpSpPr>
+        <a:xfrm>
+          <a:off x="0" y="0"/>
+          <a:ext cx="0" cy="0"/>
+          <a:chOff x="0" y="0"/>
+          <a:chExt cx="0" cy="0"/>
+        </a:xfrm>
+      </p:grpSpPr>
       <p:sp>
         <p:nvSpPr>
           <p:cNvPr id="2" name="Rectangle 1"/>
@@ -5574,6 +5653,7 @@
           <a:lstStyle/>
           <a:p>
             <a:pPr algn="ctr"/>
+            <a:endParaRPr/>
           </a:p>
         </p:txBody>
       </p:sp>
@@ -5666,6 +5746,7 @@
           <a:lstStyle/>
           <a:p>
             <a:pPr algn="ctr"/>
+            <a:endParaRPr/>
           </a:p>
         </p:txBody>
       </p:sp>
@@ -5711,6 +5792,7 @@
           <a:lstStyle/>
           <a:p>
             <a:pPr algn="ctr"/>
+            <a:endParaRPr/>
           </a:p>
         </p:txBody>
       </p:sp>
@@ -5731,7 +5813,7 @@
           <a:noFill/>
         </p:spPr>
         <p:txBody>
-          <a:bodyPr wrap="square" lIns="0" rIns="0" tIns="0" bIns="0">
+          <a:bodyPr wrap="square" lIns="0" tIns="0" rIns="0" bIns="0">
             <a:spAutoFit/>
           </a:bodyPr>
           <a:lstStyle/>
@@ -5831,6 +5913,7 @@
           <a:lstStyle/>
           <a:p>
             <a:pPr algn="ctr"/>
+            <a:endParaRPr/>
           </a:p>
         </p:txBody>
       </p:sp>
@@ -5851,7 +5934,7 @@
           <a:noFill/>
         </p:spPr>
         <p:txBody>
-          <a:bodyPr wrap="square" lIns="0" rIns="0" tIns="0" bIns="0">
+          <a:bodyPr wrap="square" lIns="0" tIns="0" rIns="0" bIns="0">
             <a:spAutoFit/>
           </a:bodyPr>
           <a:lstStyle/>
@@ -5951,6 +6034,7 @@
           <a:lstStyle/>
           <a:p>
             <a:pPr algn="ctr"/>
+            <a:endParaRPr/>
           </a:p>
         </p:txBody>
       </p:sp>
@@ -5971,7 +6055,7 @@
           <a:noFill/>
         </p:spPr>
         <p:txBody>
-          <a:bodyPr wrap="square" lIns="0" rIns="0" tIns="0" bIns="0">
+          <a:bodyPr wrap="square" lIns="0" tIns="0" rIns="0" bIns="0">
             <a:spAutoFit/>
           </a:bodyPr>
           <a:lstStyle/>
@@ -6095,6 +6179,7 @@
           <a:lstStyle/>
           <a:p>
             <a:pPr algn="ctr"/>
+            <a:endParaRPr/>
           </a:p>
         </p:txBody>
       </p:sp>
@@ -6115,7 +6200,7 @@
           <a:noFill/>
         </p:spPr>
         <p:txBody>
-          <a:bodyPr wrap="square" lIns="0" rIns="0" tIns="0" bIns="0">
+          <a:bodyPr wrap="square" lIns="0" tIns="0" rIns="0" bIns="0">
             <a:spAutoFit/>
           </a:bodyPr>
           <a:lstStyle/>
@@ -6202,7 +6287,7 @@
 </file>
 
 <file path=ppt/slides/slide13.xml><?xml version="1.0" encoding="utf-8"?>
-<p:sld xmlns:a="http://schemas.openxmlformats.org/drawingml/2006/main" xmlns:p="http://schemas.openxmlformats.org/presentationml/2006/main" xmlns:r="http://schemas.openxmlformats.org/officeDocument/2006/relationships">
+<p:sld xmlns:a="http://schemas.openxmlformats.org/drawingml/2006/main" xmlns:r="http://schemas.openxmlformats.org/officeDocument/2006/relationships" xmlns:p="http://schemas.openxmlformats.org/presentationml/2006/main">
   <p:cSld>
     <p:spTree>
       <p:nvGrpSpPr>
@@ -6210,7 +6295,14 @@
         <p:cNvGrpSpPr/>
         <p:nvPr/>
       </p:nvGrpSpPr>
-      <p:grpSpPr/>
+      <p:grpSpPr>
+        <a:xfrm>
+          <a:off x="0" y="0"/>
+          <a:ext cx="0" cy="0"/>
+          <a:chOff x="0" y="0"/>
+          <a:chExt cx="0" cy="0"/>
+        </a:xfrm>
+      </p:grpSpPr>
       <p:sp>
         <p:nvSpPr>
           <p:cNvPr id="2" name="Rectangle 1"/>
@@ -6253,6 +6345,7 @@
           <a:lstStyle/>
           <a:p>
             <a:pPr algn="ctr"/>
+            <a:endParaRPr/>
           </a:p>
         </p:txBody>
       </p:sp>
@@ -6345,6 +6438,7 @@
           <a:lstStyle/>
           <a:p>
             <a:pPr algn="ctr"/>
+            <a:endParaRPr/>
           </a:p>
         </p:txBody>
       </p:sp>
@@ -6390,6 +6484,7 @@
           <a:lstStyle/>
           <a:p>
             <a:pPr algn="ctr"/>
+            <a:endParaRPr/>
           </a:p>
         </p:txBody>
       </p:sp>
@@ -6410,7 +6505,7 @@
           <a:noFill/>
         </p:spPr>
         <p:txBody>
-          <a:bodyPr wrap="square" lIns="0" rIns="0" tIns="0" bIns="0">
+          <a:bodyPr wrap="square" lIns="0" tIns="0" rIns="0" bIns="0">
             <a:spAutoFit/>
           </a:bodyPr>
           <a:lstStyle/>
@@ -6508,6 +6603,7 @@
           <a:lstStyle/>
           <a:p>
             <a:pPr algn="ctr"/>
+            <a:endParaRPr/>
           </a:p>
         </p:txBody>
       </p:sp>
@@ -6528,7 +6624,7 @@
           <a:noFill/>
         </p:spPr>
         <p:txBody>
-          <a:bodyPr wrap="square" lIns="0" rIns="0" tIns="0" bIns="0">
+          <a:bodyPr wrap="square" lIns="0" tIns="0" rIns="0" bIns="0">
             <a:spAutoFit/>
           </a:bodyPr>
           <a:lstStyle/>
@@ -6626,6 +6722,7 @@
           <a:lstStyle/>
           <a:p>
             <a:pPr algn="ctr"/>
+            <a:endParaRPr/>
           </a:p>
         </p:txBody>
       </p:sp>
@@ -6646,7 +6743,7 @@
           <a:noFill/>
         </p:spPr>
         <p:txBody>
-          <a:bodyPr wrap="square" lIns="0" rIns="0" tIns="0" bIns="0">
+          <a:bodyPr wrap="square" lIns="0" tIns="0" rIns="0" bIns="0">
             <a:spAutoFit/>
           </a:bodyPr>
           <a:lstStyle/>
@@ -6744,6 +6841,7 @@
           <a:lstStyle/>
           <a:p>
             <a:pPr algn="ctr"/>
+            <a:endParaRPr/>
           </a:p>
         </p:txBody>
       </p:sp>
@@ -6764,7 +6862,7 @@
           <a:noFill/>
         </p:spPr>
         <p:txBody>
-          <a:bodyPr wrap="square" lIns="0" rIns="0" tIns="0" bIns="0">
+          <a:bodyPr wrap="square" lIns="0" tIns="0" rIns="0" bIns="0">
             <a:spAutoFit/>
           </a:bodyPr>
           <a:lstStyle/>
@@ -6862,6 +6960,7 @@
           <a:lstStyle/>
           <a:p>
             <a:pPr algn="ctr"/>
+            <a:endParaRPr/>
           </a:p>
         </p:txBody>
       </p:sp>
@@ -6882,7 +6981,7 @@
           <a:noFill/>
         </p:spPr>
         <p:txBody>
-          <a:bodyPr wrap="square" lIns="0" rIns="0" tIns="0" bIns="0">
+          <a:bodyPr wrap="square" lIns="0" tIns="0" rIns="0" bIns="0">
             <a:spAutoFit/>
           </a:bodyPr>
           <a:lstStyle/>

</xml_diff>

<commit_message>
feat: add Idle Money automation and FIFO lot deduction engine for Google Sheets scanner
</commit_message>
<xml_diff>
--- a/Darvas_Strategy_Rulebook_Deck_v2.pptx
+++ b/Darvas_Strategy_Rulebook_Deck_v2.pptx
@@ -3157,7 +3157,7 @@
         <p:spPr>
           <a:xfrm>
             <a:off x="914400" y="1737360"/>
-            <a:ext cx="10332720" cy="1328569"/>
+            <a:ext cx="10332720" cy="1015663"/>
           </a:xfrm>
           <a:prstGeom prst="rect">
             <a:avLst/>
@@ -3178,49 +3178,18 @@
               </a:defRPr>
             </a:pPr>
             <a:r>
-              <a:rPr lang="en-IN" dirty="0"/>
+              <a:rPr lang="en-IN" sz="6000" dirty="0"/>
               <a:t>Multi Engine </a:t>
             </a:r>
             <a:r>
-              <a:rPr dirty="0"/>
+              <a:rPr sz="6000" dirty="0"/>
               <a:t>Darvas </a:t>
             </a:r>
             <a:r>
-              <a:rPr lang="en-IN" dirty="0"/>
+              <a:rPr lang="en-IN" sz="6000" dirty="0"/>
               <a:t>Strategy</a:t>
             </a:r>
-            <a:endParaRPr dirty="0"/>
-          </a:p>
-          <a:p>
-            <a:pPr>
-              <a:spcBef>
-                <a:spcPts val="1000"/>
-              </a:spcBef>
-              <a:defRPr sz="1700">
-                <a:solidFill>
-                  <a:srgbClr val="94A3B8"/>
-                </a:solidFill>
-              </a:defRPr>
-            </a:pPr>
-            <a:r>
-              <a:rPr dirty="0"/>
-              <a:t>Operational Rulebook &amp; Behind-the-Scenes </a:t>
-            </a:r>
-            <a:r>
-              <a:rPr dirty="0" err="1"/>
-              <a:t>Backtesting</a:t>
-            </a:r>
-            <a:r>
-              <a:rPr dirty="0"/>
-              <a:t> Mechanics</a:t>
-            </a:r>
-            <a:br>
-              <a:rPr dirty="0"/>
-            </a:br>
-            <a:r>
-              <a:rPr dirty="0"/>
-              <a:t>4-Tranche Capital Architecture (Rs. 40,000 Portfolio) | Live Case Study: INFY (Infosys Ltd)</a:t>
-            </a:r>
+            <a:endParaRPr sz="6000" dirty="0"/>
           </a:p>
         </p:txBody>
       </p:sp>
@@ -3411,9 +3380,26 @@
               </a:defRPr>
             </a:pPr>
             <a:r>
+              <a:rPr lang="en-IN" dirty="0"/>
+              <a:t>INFY</a:t>
+            </a:r>
+            <a:r>
               <a:rPr dirty="0"/>
-              <a:t>LIVE INFY PROOF</a:t>
-            </a:r>
+              <a:t> </a:t>
+            </a:r>
+            <a:r>
+              <a:rPr lang="en-IN" dirty="0"/>
+              <a:t>BACKTEST</a:t>
+            </a:r>
+            <a:r>
+              <a:rPr dirty="0"/>
+              <a:t> </a:t>
+            </a:r>
+            <a:r>
+              <a:rPr lang="en-IN" dirty="0"/>
+              <a:t>CASE STUDY</a:t>
+            </a:r>
+            <a:endParaRPr dirty="0"/>
           </a:p>
           <a:p>
             <a:pPr>
@@ -3428,7 +3414,7 @@
             </a:pPr>
             <a:r>
               <a:rPr dirty="0"/>
-              <a:t>100% win rate on 33 closed trades, +Rs. 40,724 cash profit (+101.8% gain) from 2020-2026!</a:t>
+              <a:t>+Rs. 40,724 cash profit (+101.8% gain) from 2020-2026!</a:t>
             </a:r>
           </a:p>
         </p:txBody>
@@ -7033,7 +7019,7 @@
         <p:spPr>
           <a:xfrm>
             <a:off x="731520" y="365760"/>
-            <a:ext cx="10698480" cy="822960"/>
+            <a:ext cx="10698480" cy="338554"/>
           </a:xfrm>
           <a:prstGeom prst="rect">
             <a:avLst/>
@@ -7047,18 +7033,6 @@
           <a:lstStyle/>
           <a:p>
             <a:pPr>
-              <a:defRPr sz="1000" b="1">
-                <a:solidFill>
-                  <a:srgbClr val="2563EB"/>
-                </a:solidFill>
-              </a:defRPr>
-            </a:pPr>
-            <a:r>
-              <a:t>OPERATIONAL RULEBOOK</a:t>
-            </a:r>
-          </a:p>
-          <a:p>
-            <a:pPr>
               <a:defRPr sz="2200" b="1">
                 <a:solidFill>
                   <a:srgbClr val="0F172A"/>
@@ -7066,6 +7040,7 @@
               </a:defRPr>
             </a:pPr>
             <a:r>
+              <a:rPr dirty="0"/>
               <a:t>The Core Architecture: Two Complementary Engines in One System</a:t>
             </a:r>
           </a:p>
@@ -7172,7 +7147,7 @@
         <p:spPr>
           <a:xfrm>
             <a:off x="1005840" y="1645920"/>
-            <a:ext cx="4572000" cy="4480560"/>
+            <a:ext cx="4572000" cy="2431435"/>
           </a:xfrm>
           <a:prstGeom prst="rect">
             <a:avLst/>
@@ -7193,6 +7168,7 @@
               </a:defRPr>
             </a:pPr>
             <a:r>
+              <a:rPr dirty="0"/>
               <a:t>⚠️ THE TRADITIONAL INVESTING DILEMMA</a:t>
             </a:r>
           </a:p>
@@ -7208,7 +7184,12 @@
               </a:defRPr>
             </a:pPr>
             <a:r>
-              <a:t>Markets Chop 70% of the Time 📉</a:t>
+              <a:rPr lang="en-IN" dirty="0"/>
+              <a:t>How to trade when market is Bearish</a:t>
+            </a:r>
+            <a:r>
+              <a:rPr dirty="0"/>
+              <a:t>📉</a:t>
             </a:r>
           </a:p>
           <a:p>
@@ -7220,6 +7201,7 @@
               </a:defRPr>
             </a:pPr>
             <a:r>
+              <a:rPr dirty="0"/>
               <a:t>Stocks rarely go straight up. Most of the year is spent in frustrating pullbacks, corrections, and sideways channels.</a:t>
             </a:r>
           </a:p>
@@ -7235,7 +7217,12 @@
               </a:defRPr>
             </a:pPr>
             <a:r>
-              <a:t>Traditional Buy-and-Hold Gets Trapped ⏳</a:t>
+              <a:rPr lang="en-IN" dirty="0"/>
+              <a:t>How to trade when market is Bullish</a:t>
+            </a:r>
+            <a:r>
+              <a:rPr dirty="0"/>
+              <a:t> ⏳</a:t>
             </a:r>
           </a:p>
           <a:p>
@@ -7247,6 +7234,7 @@
               </a:defRPr>
             </a:pPr>
             <a:r>
+              <a:rPr dirty="0"/>
               <a:t>Investors sit on idle capital or suffer severe drawdowns waiting years for a stock to recover from cyclical dips.</a:t>
             </a:r>
           </a:p>
@@ -7262,6 +7250,7 @@
               </a:defRPr>
             </a:pPr>
             <a:r>
+              <a:rPr dirty="0"/>
               <a:t>Pure Momentum Strategies Get Whiplashed 🌪️</a:t>
             </a:r>
           </a:p>
@@ -7274,6 +7263,7 @@
               </a:defRPr>
             </a:pPr>
             <a:r>
+              <a:rPr dirty="0"/>
               <a:t>Buying only at new highs often results in buying at market tops and getting panicked into selling at bottoms.</a:t>
             </a:r>
           </a:p>

</xml_diff>

<commit_message>
feat: add portfolio simulator and web interface for multi-stock universe backtesting
</commit_message>
<xml_diff>
--- a/Darvas_Strategy_Rulebook_Deck_v2.pptx
+++ b/Darvas_Strategy_Rulebook_Deck_v2.pptx
@@ -316,7 +316,7 @@
           <a:p>
             <a:fld id="{5BCAD085-E8A6-8845-BD4E-CB4CCA059FC4}" type="datetimeFigureOut">
               <a:rPr lang="en-US" smtClean="0"/>
-              <a:t>10/30/2026</a:t>
+              <a:t>10/31/2026</a:t>
             </a:fld>
             <a:endParaRPr lang="en-US"/>
           </a:p>
@@ -484,7 +484,7 @@
           <a:p>
             <a:fld id="{5BCAD085-E8A6-8845-BD4E-CB4CCA059FC4}" type="datetimeFigureOut">
               <a:rPr lang="en-US" smtClean="0"/>
-              <a:t>10/30/2026</a:t>
+              <a:t>10/31/2026</a:t>
             </a:fld>
             <a:endParaRPr lang="en-US"/>
           </a:p>
@@ -662,7 +662,7 @@
           <a:p>
             <a:fld id="{5BCAD085-E8A6-8845-BD4E-CB4CCA059FC4}" type="datetimeFigureOut">
               <a:rPr lang="en-US" smtClean="0"/>
-              <a:t>10/30/2026</a:t>
+              <a:t>10/31/2026</a:t>
             </a:fld>
             <a:endParaRPr lang="en-US"/>
           </a:p>
@@ -830,7 +830,7 @@
           <a:p>
             <a:fld id="{5BCAD085-E8A6-8845-BD4E-CB4CCA059FC4}" type="datetimeFigureOut">
               <a:rPr lang="en-US" smtClean="0"/>
-              <a:t>10/30/2026</a:t>
+              <a:t>10/31/2026</a:t>
             </a:fld>
             <a:endParaRPr lang="en-US"/>
           </a:p>
@@ -1075,7 +1075,7 @@
           <a:p>
             <a:fld id="{5BCAD085-E8A6-8845-BD4E-CB4CCA059FC4}" type="datetimeFigureOut">
               <a:rPr lang="en-US" smtClean="0"/>
-              <a:t>10/30/2026</a:t>
+              <a:t>10/31/2026</a:t>
             </a:fld>
             <a:endParaRPr lang="en-US"/>
           </a:p>
@@ -1360,7 +1360,7 @@
           <a:p>
             <a:fld id="{5BCAD085-E8A6-8845-BD4E-CB4CCA059FC4}" type="datetimeFigureOut">
               <a:rPr lang="en-US" smtClean="0"/>
-              <a:t>10/30/2026</a:t>
+              <a:t>10/31/2026</a:t>
             </a:fld>
             <a:endParaRPr lang="en-US"/>
           </a:p>
@@ -1779,7 +1779,7 @@
           <a:p>
             <a:fld id="{5BCAD085-E8A6-8845-BD4E-CB4CCA059FC4}" type="datetimeFigureOut">
               <a:rPr lang="en-US" smtClean="0"/>
-              <a:t>10/30/2026</a:t>
+              <a:t>10/31/2026</a:t>
             </a:fld>
             <a:endParaRPr lang="en-US"/>
           </a:p>
@@ -1896,7 +1896,7 @@
           <a:p>
             <a:fld id="{5BCAD085-E8A6-8845-BD4E-CB4CCA059FC4}" type="datetimeFigureOut">
               <a:rPr lang="en-US" smtClean="0"/>
-              <a:t>10/30/2026</a:t>
+              <a:t>10/31/2026</a:t>
             </a:fld>
             <a:endParaRPr lang="en-US"/>
           </a:p>
@@ -1991,7 +1991,7 @@
           <a:p>
             <a:fld id="{5BCAD085-E8A6-8845-BD4E-CB4CCA059FC4}" type="datetimeFigureOut">
               <a:rPr lang="en-US" smtClean="0"/>
-              <a:t>10/30/2026</a:t>
+              <a:t>10/31/2026</a:t>
             </a:fld>
             <a:endParaRPr lang="en-US"/>
           </a:p>
@@ -2266,7 +2266,7 @@
           <a:p>
             <a:fld id="{5BCAD085-E8A6-8845-BD4E-CB4CCA059FC4}" type="datetimeFigureOut">
               <a:rPr lang="en-US" smtClean="0"/>
-              <a:t>10/30/2026</a:t>
+              <a:t>10/31/2026</a:t>
             </a:fld>
             <a:endParaRPr lang="en-US"/>
           </a:p>
@@ -2518,7 +2518,7 @@
           <a:p>
             <a:fld id="{5BCAD085-E8A6-8845-BD4E-CB4CCA059FC4}" type="datetimeFigureOut">
               <a:rPr lang="en-US" smtClean="0"/>
-              <a:t>10/30/2026</a:t>
+              <a:t>10/31/2026</a:t>
             </a:fld>
             <a:endParaRPr lang="en-US"/>
           </a:p>
@@ -2729,7 +2729,7 @@
           <a:p>
             <a:fld id="{5BCAD085-E8A6-8845-BD4E-CB4CCA059FC4}" type="datetimeFigureOut">
               <a:rPr lang="en-US" smtClean="0"/>
-              <a:t>10/30/2026</a:t>
+              <a:t>10/31/2026</a:t>
             </a:fld>
             <a:endParaRPr lang="en-US"/>
           </a:p>
@@ -3236,12 +3236,8 @@
               </a:defRPr>
             </a:pPr>
             <a:r>
-              <a:rPr lang="en-IN" sz="1600" dirty="0">
-                <a:solidFill>
-                  <a:schemeClr val="bg1"/>
-                </a:solidFill>
-              </a:rPr>
-              <a:t>⤴</a:t>
+              <a:rPr lang="en-IN" sz="1600" dirty="0"/>
+              <a:t>📉</a:t>
             </a:r>
             <a:r>
               <a:rPr lang="en-IN" dirty="0"/>

</xml_diff>